<commit_message>
Update STOMP presentation: Replace existing PowerPoint file with finalized version
</commit_message>
<xml_diff>
--- a/presentation/STOMP_MatrixProfile_Presentation.pptx
+++ b/presentation/STOMP_MatrixProfile_Presentation.pptx
@@ -5,17 +5,17 @@
     <p:sldMasterId id="2147483648" r:id="rId1"/>
   </p:sldMasterIdLst>
   <p:sldIdLst>
-    <p:sldId id="256" r:id="rId2"/>
-    <p:sldId id="257" r:id="rId3"/>
-    <p:sldId id="258" r:id="rId4"/>
-    <p:sldId id="259" r:id="rId5"/>
-    <p:sldId id="260" r:id="rId6"/>
-    <p:sldId id="261" r:id="rId7"/>
-    <p:sldId id="262" r:id="rId8"/>
-    <p:sldId id="263" r:id="rId9"/>
-    <p:sldId id="264" r:id="rId10"/>
+    <p:sldId id="256" r:id="rId7"/>
+    <p:sldId id="257" r:id="rId8"/>
+    <p:sldId id="258" r:id="rId9"/>
+    <p:sldId id="259" r:id="rId10"/>
+    <p:sldId id="260" r:id="rId11"/>
+    <p:sldId id="261" r:id="rId12"/>
+    <p:sldId id="262" r:id="rId13"/>
+    <p:sldId id="263" r:id="rId14"/>
+    <p:sldId id="264" r:id="rId15"/>
   </p:sldIdLst>
-  <p:sldSz cx="12188825" cy="6858000"/>
+  <p:sldSz cx="12188952" cy="6858000" type="screen4x3"/>
   <p:notesSz cx="6858000" cy="9144000"/>
   <p:defaultTextStyle>
     <a:defPPr>
@@ -112,22 +112,6 @@
       </a:defRPr>
     </a:lvl9pPr>
   </p:defaultTextStyle>
-  <p:extLst>
-    <p:ext uri="{EFAFB233-063F-42B5-8137-9DF3F51BA10A}">
-      <p15:sldGuideLst xmlns:p15="http://schemas.microsoft.com/office/powerpoint/2012/main">
-        <p15:guide id="1" orient="horz" pos="2160">
-          <p15:clr>
-            <a:srgbClr val="A4A3A4"/>
-          </p15:clr>
-        </p15:guide>
-        <p15:guide id="2" pos="2880">
-          <p15:clr>
-            <a:srgbClr val="A4A3A4"/>
-          </p15:clr>
-        </p15:guide>
-      </p15:sldGuideLst>
-    </p:ext>
-  </p:extLst>
 </p:presentation>
 </file>
 
@@ -169,9 +153,10 @@
           <a:lstStyle/>
           <a:p>
             <a:r>
-              <a:rPr lang="en-US"/>
+              <a:rPr lang="en-US" smtClean="0"/>
               <a:t>Click to edit Master title style</a:t>
             </a:r>
+            <a:endParaRPr lang="en-US"/>
           </a:p>
         </p:txBody>
       </p:sp>
@@ -287,9 +272,10 @@
           </a:lstStyle>
           <a:p>
             <a:r>
-              <a:rPr lang="en-US"/>
+              <a:rPr lang="en-US" smtClean="0"/>
               <a:t>Click to edit Master subtitle style</a:t>
             </a:r>
+            <a:endParaRPr lang="en-US"/>
           </a:p>
         </p:txBody>
       </p:sp>
@@ -310,7 +296,7 @@
           <a:p>
             <a:fld id="{5BCAD085-E8A6-8845-BD4E-CB4CCA059FC4}" type="datetimeFigureOut">
               <a:rPr lang="en-US" smtClean="0"/>
-              <a:t>5/31/2026</a:t>
+              <a:t>1/27/13</a:t>
             </a:fld>
             <a:endParaRPr lang="en-US"/>
           </a:p>
@@ -404,9 +390,10 @@
           <a:lstStyle/>
           <a:p>
             <a:r>
-              <a:rPr lang="en-US"/>
+              <a:rPr lang="en-US" smtClean="0"/>
               <a:t>Click to edit Master title style</a:t>
             </a:r>
+            <a:endParaRPr lang="en-US"/>
           </a:p>
         </p:txBody>
       </p:sp>
@@ -427,37 +414,38 @@
           <a:p>
             <a:pPr lvl="0"/>
             <a:r>
-              <a:rPr lang="en-US"/>
+              <a:rPr lang="en-US" smtClean="0"/>
               <a:t>Click to edit Master text styles</a:t>
             </a:r>
           </a:p>
           <a:p>
             <a:pPr lvl="1"/>
             <a:r>
-              <a:rPr lang="en-US"/>
+              <a:rPr lang="en-US" smtClean="0"/>
               <a:t>Second level</a:t>
             </a:r>
           </a:p>
           <a:p>
             <a:pPr lvl="2"/>
             <a:r>
-              <a:rPr lang="en-US"/>
+              <a:rPr lang="en-US" smtClean="0"/>
               <a:t>Third level</a:t>
             </a:r>
           </a:p>
           <a:p>
             <a:pPr lvl="3"/>
             <a:r>
-              <a:rPr lang="en-US"/>
+              <a:rPr lang="en-US" smtClean="0"/>
               <a:t>Fourth level</a:t>
             </a:r>
           </a:p>
           <a:p>
             <a:pPr lvl="4"/>
             <a:r>
-              <a:rPr lang="en-US"/>
+              <a:rPr lang="en-US" smtClean="0"/>
               <a:t>Fifth level</a:t>
             </a:r>
+            <a:endParaRPr lang="en-US"/>
           </a:p>
         </p:txBody>
       </p:sp>
@@ -478,7 +466,7 @@
           <a:p>
             <a:fld id="{5BCAD085-E8A6-8845-BD4E-CB4CCA059FC4}" type="datetimeFigureOut">
               <a:rPr lang="en-US" smtClean="0"/>
-              <a:t>5/31/2026</a:t>
+              <a:t>1/27/13</a:t>
             </a:fld>
             <a:endParaRPr lang="en-US"/>
           </a:p>
@@ -577,9 +565,10 @@
           <a:lstStyle/>
           <a:p>
             <a:r>
-              <a:rPr lang="en-US"/>
+              <a:rPr lang="en-US" smtClean="0"/>
               <a:t>Click to edit Master title style</a:t>
             </a:r>
+            <a:endParaRPr lang="en-US"/>
           </a:p>
         </p:txBody>
       </p:sp>
@@ -605,37 +594,38 @@
           <a:p>
             <a:pPr lvl="0"/>
             <a:r>
-              <a:rPr lang="en-US"/>
+              <a:rPr lang="en-US" smtClean="0"/>
               <a:t>Click to edit Master text styles</a:t>
             </a:r>
           </a:p>
           <a:p>
             <a:pPr lvl="1"/>
             <a:r>
-              <a:rPr lang="en-US"/>
+              <a:rPr lang="en-US" smtClean="0"/>
               <a:t>Second level</a:t>
             </a:r>
           </a:p>
           <a:p>
             <a:pPr lvl="2"/>
             <a:r>
-              <a:rPr lang="en-US"/>
+              <a:rPr lang="en-US" smtClean="0"/>
               <a:t>Third level</a:t>
             </a:r>
           </a:p>
           <a:p>
             <a:pPr lvl="3"/>
             <a:r>
-              <a:rPr lang="en-US"/>
+              <a:rPr lang="en-US" smtClean="0"/>
               <a:t>Fourth level</a:t>
             </a:r>
           </a:p>
           <a:p>
             <a:pPr lvl="4"/>
             <a:r>
-              <a:rPr lang="en-US"/>
+              <a:rPr lang="en-US" smtClean="0"/>
               <a:t>Fifth level</a:t>
             </a:r>
+            <a:endParaRPr lang="en-US"/>
           </a:p>
         </p:txBody>
       </p:sp>
@@ -656,7 +646,7 @@
           <a:p>
             <a:fld id="{5BCAD085-E8A6-8845-BD4E-CB4CCA059FC4}" type="datetimeFigureOut">
               <a:rPr lang="en-US" smtClean="0"/>
-              <a:t>5/31/2026</a:t>
+              <a:t>1/27/13</a:t>
             </a:fld>
             <a:endParaRPr lang="en-US"/>
           </a:p>
@@ -750,9 +740,10 @@
           <a:lstStyle/>
           <a:p>
             <a:r>
-              <a:rPr lang="en-US"/>
+              <a:rPr lang="en-US" smtClean="0"/>
               <a:t>Click to edit Master title style</a:t>
             </a:r>
+            <a:endParaRPr lang="en-US"/>
           </a:p>
         </p:txBody>
       </p:sp>
@@ -773,37 +764,38 @@
           <a:p>
             <a:pPr lvl="0"/>
             <a:r>
-              <a:rPr lang="en-US"/>
+              <a:rPr lang="en-US" smtClean="0"/>
               <a:t>Click to edit Master text styles</a:t>
             </a:r>
           </a:p>
           <a:p>
             <a:pPr lvl="1"/>
             <a:r>
-              <a:rPr lang="en-US"/>
+              <a:rPr lang="en-US" smtClean="0"/>
               <a:t>Second level</a:t>
             </a:r>
           </a:p>
           <a:p>
             <a:pPr lvl="2"/>
             <a:r>
-              <a:rPr lang="en-US"/>
+              <a:rPr lang="en-US" smtClean="0"/>
               <a:t>Third level</a:t>
             </a:r>
           </a:p>
           <a:p>
             <a:pPr lvl="3"/>
             <a:r>
-              <a:rPr lang="en-US"/>
+              <a:rPr lang="en-US" smtClean="0"/>
               <a:t>Fourth level</a:t>
             </a:r>
           </a:p>
           <a:p>
             <a:pPr lvl="4"/>
             <a:r>
-              <a:rPr lang="en-US"/>
+              <a:rPr lang="en-US" smtClean="0"/>
               <a:t>Fifth level</a:t>
             </a:r>
+            <a:endParaRPr lang="en-US"/>
           </a:p>
         </p:txBody>
       </p:sp>
@@ -824,7 +816,7 @@
           <a:p>
             <a:fld id="{5BCAD085-E8A6-8845-BD4E-CB4CCA059FC4}" type="datetimeFigureOut">
               <a:rPr lang="en-US" smtClean="0"/>
-              <a:t>5/31/2026</a:t>
+              <a:t>1/27/13</a:t>
             </a:fld>
             <a:endParaRPr lang="en-US"/>
           </a:p>
@@ -927,9 +919,10 @@
           </a:lstStyle>
           <a:p>
             <a:r>
-              <a:rPr lang="en-US"/>
+              <a:rPr lang="en-US" smtClean="0"/>
               <a:t>Click to edit Master title style</a:t>
             </a:r>
+            <a:endParaRPr lang="en-US"/>
           </a:p>
         </p:txBody>
       </p:sp>
@@ -1046,7 +1039,7 @@
           <a:p>
             <a:pPr lvl="0"/>
             <a:r>
-              <a:rPr lang="en-US"/>
+              <a:rPr lang="en-US" smtClean="0"/>
               <a:t>Click to edit Master text styles</a:t>
             </a:r>
           </a:p>
@@ -1069,7 +1062,7 @@
           <a:p>
             <a:fld id="{5BCAD085-E8A6-8845-BD4E-CB4CCA059FC4}" type="datetimeFigureOut">
               <a:rPr lang="en-US" smtClean="0"/>
-              <a:t>5/31/2026</a:t>
+              <a:t>1/27/13</a:t>
             </a:fld>
             <a:endParaRPr lang="en-US"/>
           </a:p>
@@ -1163,9 +1156,10 @@
           <a:lstStyle/>
           <a:p>
             <a:r>
-              <a:rPr lang="en-US"/>
+              <a:rPr lang="en-US" smtClean="0"/>
               <a:t>Click to edit Master title style</a:t>
             </a:r>
+            <a:endParaRPr lang="en-US"/>
           </a:p>
         </p:txBody>
       </p:sp>
@@ -1219,37 +1213,38 @@
           <a:p>
             <a:pPr lvl="0"/>
             <a:r>
-              <a:rPr lang="en-US"/>
+              <a:rPr lang="en-US" smtClean="0"/>
               <a:t>Click to edit Master text styles</a:t>
             </a:r>
           </a:p>
           <a:p>
             <a:pPr lvl="1"/>
             <a:r>
-              <a:rPr lang="en-US"/>
+              <a:rPr lang="en-US" smtClean="0"/>
               <a:t>Second level</a:t>
             </a:r>
           </a:p>
           <a:p>
             <a:pPr lvl="2"/>
             <a:r>
-              <a:rPr lang="en-US"/>
+              <a:rPr lang="en-US" smtClean="0"/>
               <a:t>Third level</a:t>
             </a:r>
           </a:p>
           <a:p>
             <a:pPr lvl="3"/>
             <a:r>
-              <a:rPr lang="en-US"/>
+              <a:rPr lang="en-US" smtClean="0"/>
               <a:t>Fourth level</a:t>
             </a:r>
           </a:p>
           <a:p>
             <a:pPr lvl="4"/>
             <a:r>
-              <a:rPr lang="en-US"/>
+              <a:rPr lang="en-US" smtClean="0"/>
               <a:t>Fifth level</a:t>
             </a:r>
+            <a:endParaRPr lang="en-US"/>
           </a:p>
         </p:txBody>
       </p:sp>
@@ -1303,37 +1298,38 @@
           <a:p>
             <a:pPr lvl="0"/>
             <a:r>
-              <a:rPr lang="en-US"/>
+              <a:rPr lang="en-US" smtClean="0"/>
               <a:t>Click to edit Master text styles</a:t>
             </a:r>
           </a:p>
           <a:p>
             <a:pPr lvl="1"/>
             <a:r>
-              <a:rPr lang="en-US"/>
+              <a:rPr lang="en-US" smtClean="0"/>
               <a:t>Second level</a:t>
             </a:r>
           </a:p>
           <a:p>
             <a:pPr lvl="2"/>
             <a:r>
-              <a:rPr lang="en-US"/>
+              <a:rPr lang="en-US" smtClean="0"/>
               <a:t>Third level</a:t>
             </a:r>
           </a:p>
           <a:p>
             <a:pPr lvl="3"/>
             <a:r>
-              <a:rPr lang="en-US"/>
+              <a:rPr lang="en-US" smtClean="0"/>
               <a:t>Fourth level</a:t>
             </a:r>
           </a:p>
           <a:p>
             <a:pPr lvl="4"/>
             <a:r>
-              <a:rPr lang="en-US"/>
+              <a:rPr lang="en-US" smtClean="0"/>
               <a:t>Fifth level</a:t>
             </a:r>
+            <a:endParaRPr lang="en-US"/>
           </a:p>
         </p:txBody>
       </p:sp>
@@ -1354,7 +1350,7 @@
           <a:p>
             <a:fld id="{5BCAD085-E8A6-8845-BD4E-CB4CCA059FC4}" type="datetimeFigureOut">
               <a:rPr lang="en-US" smtClean="0"/>
-              <a:t>5/31/2026</a:t>
+              <a:t>1/27/13</a:t>
             </a:fld>
             <a:endParaRPr lang="en-US"/>
           </a:p>
@@ -1452,9 +1448,10 @@
           </a:lstStyle>
           <a:p>
             <a:r>
-              <a:rPr lang="en-US"/>
+              <a:rPr lang="en-US" smtClean="0"/>
               <a:t>Click to edit Master title style</a:t>
             </a:r>
+            <a:endParaRPr lang="en-US"/>
           </a:p>
         </p:txBody>
       </p:sp>
@@ -1517,7 +1514,7 @@
           <a:p>
             <a:pPr lvl="0"/>
             <a:r>
-              <a:rPr lang="en-US"/>
+              <a:rPr lang="en-US" smtClean="0"/>
               <a:t>Click to edit Master text styles</a:t>
             </a:r>
           </a:p>
@@ -1573,37 +1570,38 @@
           <a:p>
             <a:pPr lvl="0"/>
             <a:r>
-              <a:rPr lang="en-US"/>
+              <a:rPr lang="en-US" smtClean="0"/>
               <a:t>Click to edit Master text styles</a:t>
             </a:r>
           </a:p>
           <a:p>
             <a:pPr lvl="1"/>
             <a:r>
-              <a:rPr lang="en-US"/>
+              <a:rPr lang="en-US" smtClean="0"/>
               <a:t>Second level</a:t>
             </a:r>
           </a:p>
           <a:p>
             <a:pPr lvl="2"/>
             <a:r>
-              <a:rPr lang="en-US"/>
+              <a:rPr lang="en-US" smtClean="0"/>
               <a:t>Third level</a:t>
             </a:r>
           </a:p>
           <a:p>
             <a:pPr lvl="3"/>
             <a:r>
-              <a:rPr lang="en-US"/>
+              <a:rPr lang="en-US" smtClean="0"/>
               <a:t>Fourth level</a:t>
             </a:r>
           </a:p>
           <a:p>
             <a:pPr lvl="4"/>
             <a:r>
-              <a:rPr lang="en-US"/>
+              <a:rPr lang="en-US" smtClean="0"/>
               <a:t>Fifth level</a:t>
             </a:r>
+            <a:endParaRPr lang="en-US"/>
           </a:p>
         </p:txBody>
       </p:sp>
@@ -1666,7 +1664,7 @@
           <a:p>
             <a:pPr lvl="0"/>
             <a:r>
-              <a:rPr lang="en-US"/>
+              <a:rPr lang="en-US" smtClean="0"/>
               <a:t>Click to edit Master text styles</a:t>
             </a:r>
           </a:p>
@@ -1722,37 +1720,38 @@
           <a:p>
             <a:pPr lvl="0"/>
             <a:r>
-              <a:rPr lang="en-US"/>
+              <a:rPr lang="en-US" smtClean="0"/>
               <a:t>Click to edit Master text styles</a:t>
             </a:r>
           </a:p>
           <a:p>
             <a:pPr lvl="1"/>
             <a:r>
-              <a:rPr lang="en-US"/>
+              <a:rPr lang="en-US" smtClean="0"/>
               <a:t>Second level</a:t>
             </a:r>
           </a:p>
           <a:p>
             <a:pPr lvl="2"/>
             <a:r>
-              <a:rPr lang="en-US"/>
+              <a:rPr lang="en-US" smtClean="0"/>
               <a:t>Third level</a:t>
             </a:r>
           </a:p>
           <a:p>
             <a:pPr lvl="3"/>
             <a:r>
-              <a:rPr lang="en-US"/>
+              <a:rPr lang="en-US" smtClean="0"/>
               <a:t>Fourth level</a:t>
             </a:r>
           </a:p>
           <a:p>
             <a:pPr lvl="4"/>
             <a:r>
-              <a:rPr lang="en-US"/>
+              <a:rPr lang="en-US" smtClean="0"/>
               <a:t>Fifth level</a:t>
             </a:r>
+            <a:endParaRPr lang="en-US"/>
           </a:p>
         </p:txBody>
       </p:sp>
@@ -1773,7 +1772,7 @@
           <a:p>
             <a:fld id="{5BCAD085-E8A6-8845-BD4E-CB4CCA059FC4}" type="datetimeFigureOut">
               <a:rPr lang="en-US" smtClean="0"/>
-              <a:t>5/31/2026</a:t>
+              <a:t>1/27/13</a:t>
             </a:fld>
             <a:endParaRPr lang="en-US"/>
           </a:p>
@@ -1867,9 +1866,10 @@
           <a:lstStyle/>
           <a:p>
             <a:r>
-              <a:rPr lang="en-US"/>
+              <a:rPr lang="en-US" smtClean="0"/>
               <a:t>Click to edit Master title style</a:t>
             </a:r>
+            <a:endParaRPr lang="en-US"/>
           </a:p>
         </p:txBody>
       </p:sp>
@@ -1890,7 +1890,7 @@
           <a:p>
             <a:fld id="{5BCAD085-E8A6-8845-BD4E-CB4CCA059FC4}" type="datetimeFigureOut">
               <a:rPr lang="en-US" smtClean="0"/>
-              <a:t>5/31/2026</a:t>
+              <a:t>1/27/13</a:t>
             </a:fld>
             <a:endParaRPr lang="en-US"/>
           </a:p>
@@ -1985,7 +1985,7 @@
           <a:p>
             <a:fld id="{5BCAD085-E8A6-8845-BD4E-CB4CCA059FC4}" type="datetimeFigureOut">
               <a:rPr lang="en-US" smtClean="0"/>
-              <a:t>5/31/2026</a:t>
+              <a:t>1/27/13</a:t>
             </a:fld>
             <a:endParaRPr lang="en-US"/>
           </a:p>
@@ -2088,9 +2088,10 @@
           </a:lstStyle>
           <a:p>
             <a:r>
-              <a:rPr lang="en-US"/>
+              <a:rPr lang="en-US" smtClean="0"/>
               <a:t>Click to edit Master title style</a:t>
             </a:r>
+            <a:endParaRPr lang="en-US"/>
           </a:p>
         </p:txBody>
       </p:sp>
@@ -2144,37 +2145,38 @@
           <a:p>
             <a:pPr lvl="0"/>
             <a:r>
-              <a:rPr lang="en-US"/>
+              <a:rPr lang="en-US" smtClean="0"/>
               <a:t>Click to edit Master text styles</a:t>
             </a:r>
           </a:p>
           <a:p>
             <a:pPr lvl="1"/>
             <a:r>
-              <a:rPr lang="en-US"/>
+              <a:rPr lang="en-US" smtClean="0"/>
               <a:t>Second level</a:t>
             </a:r>
           </a:p>
           <a:p>
             <a:pPr lvl="2"/>
             <a:r>
-              <a:rPr lang="en-US"/>
+              <a:rPr lang="en-US" smtClean="0"/>
               <a:t>Third level</a:t>
             </a:r>
           </a:p>
           <a:p>
             <a:pPr lvl="3"/>
             <a:r>
-              <a:rPr lang="en-US"/>
+              <a:rPr lang="en-US" smtClean="0"/>
               <a:t>Fourth level</a:t>
             </a:r>
           </a:p>
           <a:p>
             <a:pPr lvl="4"/>
             <a:r>
-              <a:rPr lang="en-US"/>
+              <a:rPr lang="en-US" smtClean="0"/>
               <a:t>Fifth level</a:t>
             </a:r>
+            <a:endParaRPr lang="en-US"/>
           </a:p>
         </p:txBody>
       </p:sp>
@@ -2237,7 +2239,7 @@
           <a:p>
             <a:pPr lvl="0"/>
             <a:r>
-              <a:rPr lang="en-US"/>
+              <a:rPr lang="en-US" smtClean="0"/>
               <a:t>Click to edit Master text styles</a:t>
             </a:r>
           </a:p>
@@ -2260,7 +2262,7 @@
           <a:p>
             <a:fld id="{5BCAD085-E8A6-8845-BD4E-CB4CCA059FC4}" type="datetimeFigureOut">
               <a:rPr lang="en-US" smtClean="0"/>
-              <a:t>5/31/2026</a:t>
+              <a:t>1/27/13</a:t>
             </a:fld>
             <a:endParaRPr lang="en-US"/>
           </a:p>
@@ -2363,9 +2365,10 @@
           </a:lstStyle>
           <a:p>
             <a:r>
-              <a:rPr lang="en-US"/>
+              <a:rPr lang="en-US" smtClean="0"/>
               <a:t>Click to edit Master title style</a:t>
             </a:r>
+            <a:endParaRPr lang="en-US"/>
           </a:p>
         </p:txBody>
       </p:sp>
@@ -2489,7 +2492,7 @@
           <a:p>
             <a:pPr lvl="0"/>
             <a:r>
-              <a:rPr lang="en-US"/>
+              <a:rPr lang="en-US" smtClean="0"/>
               <a:t>Click to edit Master text styles</a:t>
             </a:r>
           </a:p>
@@ -2512,7 +2515,7 @@
           <a:p>
             <a:fld id="{5BCAD085-E8A6-8845-BD4E-CB4CCA059FC4}" type="datetimeFigureOut">
               <a:rPr lang="en-US" smtClean="0"/>
-              <a:t>5/31/2026</a:t>
+              <a:t>1/27/13</a:t>
             </a:fld>
             <a:endParaRPr lang="en-US"/>
           </a:p>
@@ -2621,9 +2624,10 @@
           <a:lstStyle/>
           <a:p>
             <a:r>
-              <a:rPr lang="en-US"/>
+              <a:rPr lang="en-US" smtClean="0"/>
               <a:t>Click to edit Master title style</a:t>
             </a:r>
+            <a:endParaRPr lang="en-US"/>
           </a:p>
         </p:txBody>
       </p:sp>
@@ -2654,37 +2658,38 @@
           <a:p>
             <a:pPr lvl="0"/>
             <a:r>
-              <a:rPr lang="en-US"/>
+              <a:rPr lang="en-US" smtClean="0"/>
               <a:t>Click to edit Master text styles</a:t>
             </a:r>
           </a:p>
           <a:p>
             <a:pPr lvl="1"/>
             <a:r>
-              <a:rPr lang="en-US"/>
+              <a:rPr lang="en-US" smtClean="0"/>
               <a:t>Second level</a:t>
             </a:r>
           </a:p>
           <a:p>
             <a:pPr lvl="2"/>
             <a:r>
-              <a:rPr lang="en-US"/>
+              <a:rPr lang="en-US" smtClean="0"/>
               <a:t>Third level</a:t>
             </a:r>
           </a:p>
           <a:p>
             <a:pPr lvl="3"/>
             <a:r>
-              <a:rPr lang="en-US"/>
+              <a:rPr lang="en-US" smtClean="0"/>
               <a:t>Fourth level</a:t>
             </a:r>
           </a:p>
           <a:p>
             <a:pPr lvl="4"/>
             <a:r>
-              <a:rPr lang="en-US"/>
+              <a:rPr lang="en-US" smtClean="0"/>
               <a:t>Fifth level</a:t>
             </a:r>
+            <a:endParaRPr lang="en-US"/>
           </a:p>
         </p:txBody>
       </p:sp>
@@ -2723,7 +2728,7 @@
           <a:p>
             <a:fld id="{5BCAD085-E8A6-8845-BD4E-CB4CCA059FC4}" type="datetimeFigureOut">
               <a:rPr lang="en-US" smtClean="0"/>
-              <a:t>5/31/2026</a:t>
+              <a:t>1/27/13</a:t>
             </a:fld>
             <a:endParaRPr lang="en-US"/>
           </a:p>
@@ -3082,7 +3087,7 @@
 </file>
 
 <file path=ppt/slides/slide1.xml><?xml version="1.0" encoding="utf-8"?>
-<p:sld xmlns:a="http://schemas.openxmlformats.org/drawingml/2006/main" xmlns:r="http://schemas.openxmlformats.org/officeDocument/2006/relationships" xmlns:p="http://schemas.openxmlformats.org/presentationml/2006/main">
+<p:sld xmlns:a="http://schemas.openxmlformats.org/drawingml/2006/main" xmlns:p="http://schemas.openxmlformats.org/presentationml/2006/main" xmlns:r="http://schemas.openxmlformats.org/officeDocument/2006/relationships">
   <p:cSld>
     <p:bg>
       <p:bgPr>
@@ -3098,14 +3103,7 @@
         <p:cNvGrpSpPr/>
         <p:nvPr/>
       </p:nvGrpSpPr>
-      <p:grpSpPr>
-        <a:xfrm>
-          <a:off x="0" y="0"/>
-          <a:ext cx="0" cy="0"/>
-          <a:chOff x="0" y="0"/>
-          <a:chExt cx="0" cy="0"/>
-        </a:xfrm>
-      </p:grpSpPr>
+      <p:grpSpPr/>
       <p:sp>
         <p:nvSpPr>
           <p:cNvPr id="2" name="Oval 1"/>
@@ -3146,7 +3144,6 @@
           <a:lstStyle/>
           <a:p>
             <a:pPr algn="ctr"/>
-            <a:endParaRPr/>
           </a:p>
         </p:txBody>
       </p:sp>
@@ -3190,7 +3187,6 @@
           <a:lstStyle/>
           <a:p>
             <a:pPr algn="ctr"/>
-            <a:endParaRPr/>
           </a:p>
         </p:txBody>
       </p:sp>
@@ -3234,7 +3230,6 @@
           <a:lstStyle/>
           <a:p>
             <a:pPr algn="ctr"/>
-            <a:endParaRPr/>
           </a:p>
         </p:txBody>
       </p:sp>
@@ -3278,7 +3273,6 @@
           <a:lstStyle/>
           <a:p>
             <a:pPr algn="ctr"/>
-            <a:endParaRPr/>
           </a:p>
         </p:txBody>
       </p:sp>
@@ -3462,7 +3456,6 @@
           <a:lstStyle/>
           <a:p>
             <a:pPr algn="ctr"/>
-            <a:endParaRPr/>
           </a:p>
         </p:txBody>
       </p:sp>
@@ -3541,7 +3534,6 @@
           <a:lstStyle/>
           <a:p>
             <a:pPr algn="ctr"/>
-            <a:endParaRPr/>
           </a:p>
         </p:txBody>
       </p:sp>
@@ -3585,7 +3577,6 @@
           <a:lstStyle/>
           <a:p>
             <a:pPr algn="ctr"/>
-            <a:endParaRPr/>
           </a:p>
         </p:txBody>
       </p:sp>
@@ -3741,7 +3732,7 @@
 </file>
 
 <file path=ppt/slides/slide2.xml><?xml version="1.0" encoding="utf-8"?>
-<p:sld xmlns:a="http://schemas.openxmlformats.org/drawingml/2006/main" xmlns:r="http://schemas.openxmlformats.org/officeDocument/2006/relationships" xmlns:p="http://schemas.openxmlformats.org/presentationml/2006/main">
+<p:sld xmlns:a="http://schemas.openxmlformats.org/drawingml/2006/main" xmlns:p="http://schemas.openxmlformats.org/presentationml/2006/main" xmlns:r="http://schemas.openxmlformats.org/officeDocument/2006/relationships">
   <p:cSld>
     <p:bg>
       <p:bgPr>
@@ -3757,14 +3748,7 @@
         <p:cNvGrpSpPr/>
         <p:nvPr/>
       </p:nvGrpSpPr>
-      <p:grpSpPr>
-        <a:xfrm>
-          <a:off x="0" y="0"/>
-          <a:ext cx="0" cy="0"/>
-          <a:chOff x="0" y="0"/>
-          <a:chExt cx="0" cy="0"/>
-        </a:xfrm>
-      </p:grpSpPr>
+      <p:grpSpPr/>
       <p:sp>
         <p:nvSpPr>
           <p:cNvPr id="2" name="Rectangle 1"/>
@@ -3805,7 +3789,6 @@
           <a:lstStyle/>
           <a:p>
             <a:pPr algn="ctr"/>
-            <a:endParaRPr/>
           </a:p>
         </p:txBody>
       </p:sp>
@@ -3849,7 +3832,6 @@
           <a:lstStyle/>
           <a:p>
             <a:pPr algn="ctr"/>
-            <a:endParaRPr/>
           </a:p>
         </p:txBody>
       </p:sp>
@@ -3963,7 +3945,6 @@
           <a:lstStyle/>
           <a:p>
             <a:pPr algn="ctr"/>
-            <a:endParaRPr/>
           </a:p>
         </p:txBody>
       </p:sp>
@@ -4007,7 +3988,6 @@
           <a:lstStyle/>
           <a:p>
             <a:pPr algn="ctr"/>
-            <a:endParaRPr/>
           </a:p>
         </p:txBody>
       </p:sp>
@@ -4123,7 +4103,6 @@
           <a:lstStyle/>
           <a:p>
             <a:pPr algn="ctr"/>
-            <a:endParaRPr/>
           </a:p>
         </p:txBody>
       </p:sp>
@@ -4237,7 +4216,6 @@
           <a:lstStyle/>
           <a:p>
             <a:pPr algn="ctr"/>
-            <a:endParaRPr/>
           </a:p>
         </p:txBody>
       </p:sp>
@@ -4387,7 +4365,6 @@
           <a:lstStyle/>
           <a:p>
             <a:pPr algn="ctr"/>
-            <a:endParaRPr/>
           </a:p>
         </p:txBody>
       </p:sp>
@@ -4537,7 +4514,6 @@
           <a:lstStyle/>
           <a:p>
             <a:pPr algn="ctr"/>
-            <a:endParaRPr/>
           </a:p>
         </p:txBody>
       </p:sp>
@@ -4687,7 +4663,6 @@
           <a:lstStyle/>
           <a:p>
             <a:pPr algn="ctr"/>
-            <a:endParaRPr/>
           </a:p>
         </p:txBody>
       </p:sp>
@@ -4837,7 +4812,6 @@
           <a:lstStyle/>
           <a:p>
             <a:pPr algn="ctr"/>
-            <a:endParaRPr/>
           </a:p>
         </p:txBody>
       </p:sp>
@@ -4881,7 +4855,6 @@
           <a:lstStyle/>
           <a:p>
             <a:pPr algn="ctr"/>
-            <a:endParaRPr/>
           </a:p>
         </p:txBody>
       </p:sp>
@@ -4960,7 +4933,6 @@
           <a:lstStyle/>
           <a:p>
             <a:pPr algn="ctr"/>
-            <a:endParaRPr/>
           </a:p>
         </p:txBody>
       </p:sp>
@@ -5109,7 +5081,6 @@
           <a:lstStyle/>
           <a:p>
             <a:pPr algn="ctr"/>
-            <a:endParaRPr/>
           </a:p>
         </p:txBody>
       </p:sp>
@@ -5264,7 +5235,7 @@
 </file>
 
 <file path=ppt/slides/slide3.xml><?xml version="1.0" encoding="utf-8"?>
-<p:sld xmlns:a="http://schemas.openxmlformats.org/drawingml/2006/main" xmlns:r="http://schemas.openxmlformats.org/officeDocument/2006/relationships" xmlns:p="http://schemas.openxmlformats.org/presentationml/2006/main">
+<p:sld xmlns:a="http://schemas.openxmlformats.org/drawingml/2006/main" xmlns:p="http://schemas.openxmlformats.org/presentationml/2006/main" xmlns:r="http://schemas.openxmlformats.org/officeDocument/2006/relationships">
   <p:cSld>
     <p:bg>
       <p:bgPr>
@@ -5280,14 +5251,7 @@
         <p:cNvGrpSpPr/>
         <p:nvPr/>
       </p:nvGrpSpPr>
-      <p:grpSpPr>
-        <a:xfrm>
-          <a:off x="0" y="0"/>
-          <a:ext cx="0" cy="0"/>
-          <a:chOff x="0" y="0"/>
-          <a:chExt cx="0" cy="0"/>
-        </a:xfrm>
-      </p:grpSpPr>
+      <p:grpSpPr/>
       <p:sp>
         <p:nvSpPr>
           <p:cNvPr id="2" name="Rectangle 1"/>
@@ -5328,7 +5292,6 @@
           <a:lstStyle/>
           <a:p>
             <a:pPr algn="ctr"/>
-            <a:endParaRPr/>
           </a:p>
         </p:txBody>
       </p:sp>
@@ -5372,7 +5335,6 @@
           <a:lstStyle/>
           <a:p>
             <a:pPr algn="ctr"/>
-            <a:endParaRPr/>
           </a:p>
         </p:txBody>
       </p:sp>
@@ -5486,7 +5448,6 @@
           <a:lstStyle/>
           <a:p>
             <a:pPr algn="ctr"/>
-            <a:endParaRPr/>
           </a:p>
         </p:txBody>
       </p:sp>
@@ -5530,7 +5491,6 @@
           <a:lstStyle/>
           <a:p>
             <a:pPr algn="ctr"/>
-            <a:endParaRPr/>
           </a:p>
         </p:txBody>
       </p:sp>
@@ -5680,7 +5640,6 @@
           <a:lstStyle/>
           <a:p>
             <a:pPr algn="ctr"/>
-            <a:endParaRPr/>
           </a:p>
         </p:txBody>
       </p:sp>
@@ -5724,7 +5683,6 @@
           <a:lstStyle/>
           <a:p>
             <a:pPr algn="ctr"/>
-            <a:endParaRPr/>
           </a:p>
         </p:txBody>
       </p:sp>
@@ -5804,7 +5762,6 @@
           <a:lstStyle/>
           <a:p>
             <a:pPr algn="ctr"/>
-            <a:endParaRPr/>
           </a:p>
         </p:txBody>
       </p:sp>
@@ -5884,7 +5841,6 @@
           <a:lstStyle/>
           <a:p>
             <a:pPr algn="ctr"/>
-            <a:endParaRPr/>
           </a:p>
         </p:txBody>
       </p:sp>
@@ -5964,7 +5920,6 @@
           <a:lstStyle/>
           <a:p>
             <a:pPr algn="ctr"/>
-            <a:endParaRPr/>
           </a:p>
         </p:txBody>
       </p:sp>
@@ -6044,7 +5999,6 @@
           <a:lstStyle/>
           <a:p>
             <a:pPr algn="ctr"/>
-            <a:endParaRPr/>
           </a:p>
         </p:txBody>
       </p:sp>
@@ -6088,7 +6042,6 @@
           <a:lstStyle/>
           <a:p>
             <a:pPr algn="ctr"/>
-            <a:endParaRPr/>
           </a:p>
         </p:txBody>
       </p:sp>
@@ -6237,7 +6190,6 @@
           <a:lstStyle/>
           <a:p>
             <a:pPr algn="ctr"/>
-            <a:endParaRPr/>
           </a:p>
         </p:txBody>
       </p:sp>
@@ -6281,7 +6233,6 @@
           <a:lstStyle/>
           <a:p>
             <a:pPr algn="ctr"/>
-            <a:endParaRPr/>
           </a:p>
         </p:txBody>
       </p:sp>
@@ -6430,7 +6381,6 @@
           <a:lstStyle/>
           <a:p>
             <a:pPr algn="ctr"/>
-            <a:endParaRPr/>
           </a:p>
         </p:txBody>
       </p:sp>
@@ -6474,7 +6424,6 @@
           <a:lstStyle/>
           <a:p>
             <a:pPr algn="ctr"/>
-            <a:endParaRPr/>
           </a:p>
         </p:txBody>
       </p:sp>
@@ -6658,7 +6607,6 @@
           <a:lstStyle/>
           <a:p>
             <a:pPr algn="ctr"/>
-            <a:endParaRPr/>
           </a:p>
         </p:txBody>
       </p:sp>
@@ -6702,7 +6650,6 @@
           <a:lstStyle/>
           <a:p>
             <a:pPr algn="ctr"/>
-            <a:endParaRPr/>
           </a:p>
         </p:txBody>
       </p:sp>
@@ -6817,7 +6764,6 @@
           <a:lstStyle/>
           <a:p>
             <a:pPr algn="ctr"/>
-            <a:endParaRPr/>
           </a:p>
         </p:txBody>
       </p:sp>
@@ -6861,7 +6807,6 @@
           <a:lstStyle/>
           <a:p>
             <a:pPr algn="ctr"/>
-            <a:endParaRPr/>
           </a:p>
         </p:txBody>
       </p:sp>
@@ -6976,7 +6921,6 @@
           <a:lstStyle/>
           <a:p>
             <a:pPr algn="ctr"/>
-            <a:endParaRPr/>
           </a:p>
         </p:txBody>
       </p:sp>
@@ -7020,7 +6964,6 @@
           <a:lstStyle/>
           <a:p>
             <a:pPr algn="ctr"/>
-            <a:endParaRPr/>
           </a:p>
         </p:txBody>
       </p:sp>
@@ -7135,7 +7078,6 @@
           <a:lstStyle/>
           <a:p>
             <a:pPr algn="ctr"/>
-            <a:endParaRPr/>
           </a:p>
         </p:txBody>
       </p:sp>
@@ -7179,7 +7121,6 @@
           <a:lstStyle/>
           <a:p>
             <a:pPr algn="ctr"/>
-            <a:endParaRPr/>
           </a:p>
         </p:txBody>
       </p:sp>
@@ -7263,7 +7204,7 @@
 </file>
 
 <file path=ppt/slides/slide4.xml><?xml version="1.0" encoding="utf-8"?>
-<p:sld xmlns:a="http://schemas.openxmlformats.org/drawingml/2006/main" xmlns:r="http://schemas.openxmlformats.org/officeDocument/2006/relationships" xmlns:p="http://schemas.openxmlformats.org/presentationml/2006/main">
+<p:sld xmlns:a="http://schemas.openxmlformats.org/drawingml/2006/main" xmlns:p="http://schemas.openxmlformats.org/presentationml/2006/main" xmlns:r="http://schemas.openxmlformats.org/officeDocument/2006/relationships">
   <p:cSld>
     <p:bg>
       <p:bgPr>
@@ -7279,14 +7220,7 @@
         <p:cNvGrpSpPr/>
         <p:nvPr/>
       </p:nvGrpSpPr>
-      <p:grpSpPr>
-        <a:xfrm>
-          <a:off x="0" y="0"/>
-          <a:ext cx="0" cy="0"/>
-          <a:chOff x="0" y="0"/>
-          <a:chExt cx="0" cy="0"/>
-        </a:xfrm>
-      </p:grpSpPr>
+      <p:grpSpPr/>
       <p:sp>
         <p:nvSpPr>
           <p:cNvPr id="2" name="Rectangle 1"/>
@@ -7327,7 +7261,6 @@
           <a:lstStyle/>
           <a:p>
             <a:pPr algn="ctr"/>
-            <a:endParaRPr/>
           </a:p>
         </p:txBody>
       </p:sp>
@@ -7371,7 +7304,6 @@
           <a:lstStyle/>
           <a:p>
             <a:pPr algn="ctr"/>
-            <a:endParaRPr/>
           </a:p>
         </p:txBody>
       </p:sp>
@@ -7485,7 +7417,6 @@
           <a:lstStyle/>
           <a:p>
             <a:pPr algn="ctr"/>
-            <a:endParaRPr/>
           </a:p>
         </p:txBody>
       </p:sp>
@@ -7564,7 +7495,6 @@
           <a:lstStyle/>
           <a:p>
             <a:pPr algn="ctr"/>
-            <a:endParaRPr/>
           </a:p>
         </p:txBody>
       </p:sp>
@@ -7608,7 +7538,6 @@
           <a:lstStyle/>
           <a:p>
             <a:pPr algn="ctr"/>
-            <a:endParaRPr/>
           </a:p>
         </p:txBody>
       </p:sp>
@@ -7714,7 +7643,7 @@
                 <a:latin typeface="Calibri"/>
               </a:rPr>
               <a:t>Random time series:
-1M · 10M · 50M points
+100K · 1M points
 Seed: 2021402216</a:t>
             </a:r>
           </a:p>
@@ -7760,7 +7689,6 @@
           <a:lstStyle/>
           <a:p>
             <a:pPr algn="ctr"/>
-            <a:endParaRPr/>
           </a:p>
         </p:txBody>
       </p:sp>
@@ -7804,7 +7732,6 @@
           <a:lstStyle/>
           <a:p>
             <a:pPr algn="ctr"/>
-            <a:endParaRPr/>
           </a:p>
         </p:txBody>
       </p:sp>
@@ -7956,7 +7883,6 @@
           <a:lstStyle/>
           <a:p>
             <a:pPr algn="ctr"/>
-            <a:endParaRPr/>
           </a:p>
         </p:txBody>
       </p:sp>
@@ -8000,7 +7926,6 @@
           <a:lstStyle/>
           <a:p>
             <a:pPr algn="ctr"/>
-            <a:endParaRPr/>
           </a:p>
         </p:txBody>
       </p:sp>
@@ -8152,7 +8077,6 @@
           <a:lstStyle/>
           <a:p>
             <a:pPr algn="ctr"/>
-            <a:endParaRPr/>
           </a:p>
         </p:txBody>
       </p:sp>
@@ -8196,7 +8120,6 @@
           <a:lstStyle/>
           <a:p>
             <a:pPr algn="ctr"/>
-            <a:endParaRPr/>
           </a:p>
         </p:txBody>
       </p:sp>
@@ -8348,7 +8271,6 @@
           <a:lstStyle/>
           <a:p>
             <a:pPr algn="ctr"/>
-            <a:endParaRPr/>
           </a:p>
         </p:txBody>
       </p:sp>
@@ -8500,8 +8422,8 @@
         </p:nvSpPr>
         <p:spPr>
           <a:xfrm>
-            <a:off x="5897880" y="5440680"/>
-            <a:ext cx="2057399" cy="276999"/>
+            <a:off x="6126479" y="5440680"/>
+            <a:ext cx="1828800" cy="411480"/>
           </a:xfrm>
           <a:prstGeom prst="rect">
             <a:avLst/>
@@ -8516,7 +8438,7 @@
           <a:p>
             <a:pPr algn="l"/>
             <a:r>
-              <a:rPr sz="1200" b="1" i="0" dirty="0">
+              <a:rPr sz="1200" b="1" i="0">
                 <a:solidFill>
                   <a:srgbClr val="FFFFFF"/>
                 </a:solidFill>
@@ -8592,7 +8514,7 @@
                 </a:solidFill>
                 <a:latin typeface="Calibri"/>
               </a:rPr>
-              <a:t>1M · 10M · 50M points</a:t>
+              <a:t>100K · 1M points</a:t>
             </a:r>
           </a:p>
         </p:txBody>
@@ -8640,8 +8562,8 @@
         </p:nvSpPr>
         <p:spPr>
           <a:xfrm>
-            <a:off x="5897880" y="5943600"/>
-            <a:ext cx="2057399" cy="276999"/>
+            <a:off x="6126479" y="5943600"/>
+            <a:ext cx="1828800" cy="411480"/>
           </a:xfrm>
           <a:prstGeom prst="rect">
             <a:avLst/>
@@ -8656,7 +8578,7 @@
           <a:p>
             <a:pPr algn="l"/>
             <a:r>
-              <a:rPr sz="1200" b="1" i="0" dirty="0">
+              <a:rPr sz="1200" b="1" i="0">
                 <a:solidFill>
                   <a:srgbClr val="FFFFFF"/>
                 </a:solidFill>
@@ -8707,7 +8629,6 @@
           <a:lstStyle/>
           <a:p>
             <a:pPr algn="ctr"/>
-            <a:endParaRPr/>
           </a:p>
         </p:txBody>
       </p:sp>
@@ -8751,7 +8672,6 @@
           <a:lstStyle/>
           <a:p>
             <a:pPr algn="ctr"/>
-            <a:endParaRPr/>
           </a:p>
         </p:txBody>
       </p:sp>
@@ -8837,7 +8757,7 @@
 </file>
 
 <file path=ppt/slides/slide5.xml><?xml version="1.0" encoding="utf-8"?>
-<p:sld xmlns:a="http://schemas.openxmlformats.org/drawingml/2006/main" xmlns:r="http://schemas.openxmlformats.org/officeDocument/2006/relationships" xmlns:p="http://schemas.openxmlformats.org/presentationml/2006/main">
+<p:sld xmlns:a="http://schemas.openxmlformats.org/drawingml/2006/main" xmlns:p="http://schemas.openxmlformats.org/presentationml/2006/main" xmlns:r="http://schemas.openxmlformats.org/officeDocument/2006/relationships">
   <p:cSld>
     <p:bg>
       <p:bgPr>
@@ -8853,14 +8773,7 @@
         <p:cNvGrpSpPr/>
         <p:nvPr/>
       </p:nvGrpSpPr>
-      <p:grpSpPr>
-        <a:xfrm>
-          <a:off x="0" y="0"/>
-          <a:ext cx="0" cy="0"/>
-          <a:chOff x="0" y="0"/>
-          <a:chExt cx="0" cy="0"/>
-        </a:xfrm>
-      </p:grpSpPr>
+      <p:grpSpPr/>
       <p:sp>
         <p:nvSpPr>
           <p:cNvPr id="2" name="Rectangle 1"/>
@@ -8901,7 +8814,6 @@
           <a:lstStyle/>
           <a:p>
             <a:pPr algn="ctr"/>
-            <a:endParaRPr/>
           </a:p>
         </p:txBody>
       </p:sp>
@@ -8945,7 +8857,6 @@
           <a:lstStyle/>
           <a:p>
             <a:pPr algn="ctr"/>
-            <a:endParaRPr/>
           </a:p>
         </p:txBody>
       </p:sp>
@@ -9027,8 +8938,8 @@
         </p:nvSpPr>
         <p:spPr>
           <a:xfrm>
-            <a:off x="365760" y="1234440"/>
-            <a:ext cx="3657600" cy="2468880"/>
+            <a:off x="448056" y="1234440"/>
+            <a:ext cx="5303520" cy="2468880"/>
           </a:xfrm>
           <a:prstGeom prst="rect">
             <a:avLst/>
@@ -9059,7 +8970,6 @@
           <a:lstStyle/>
           <a:p>
             <a:pPr algn="ctr"/>
-            <a:endParaRPr/>
           </a:p>
         </p:txBody>
       </p:sp>
@@ -9071,8 +8981,8 @@
         </p:nvSpPr>
         <p:spPr>
           <a:xfrm>
-            <a:off x="365760" y="1234440"/>
-            <a:ext cx="3657600" cy="64008"/>
+            <a:off x="448056" y="1234440"/>
+            <a:ext cx="5303520" cy="64008"/>
           </a:xfrm>
           <a:prstGeom prst="rect">
             <a:avLst/>
@@ -9103,7 +9013,6 @@
           <a:lstStyle/>
           <a:p>
             <a:pPr algn="ctr"/>
-            <a:endParaRPr/>
           </a:p>
         </p:txBody>
       </p:sp>
@@ -9115,29 +9024,29 @@
         </p:nvSpPr>
         <p:spPr>
           <a:xfrm>
-            <a:off x="365760" y="1389888"/>
-            <a:ext cx="3657600" cy="868680"/>
-          </a:xfrm>
-          <a:prstGeom prst="rect">
-            <a:avLst/>
-          </a:prstGeom>
-          <a:noFill/>
-        </p:spPr>
-        <p:txBody>
-          <a:bodyPr wrap="square">
-            <a:spAutoFit/>
-          </a:bodyPr>
-          <a:lstStyle/>
-          <a:p>
-            <a:pPr algn="ctr"/>
-            <a:r>
-              <a:rPr sz="5200" b="1" i="0">
+            <a:off x="448056" y="1371600"/>
+            <a:ext cx="5303520" cy="868680"/>
+          </a:xfrm>
+          <a:prstGeom prst="rect">
+            <a:avLst/>
+          </a:prstGeom>
+          <a:noFill/>
+        </p:spPr>
+        <p:txBody>
+          <a:bodyPr wrap="square">
+            <a:spAutoFit/>
+          </a:bodyPr>
+          <a:lstStyle/>
+          <a:p>
+            <a:pPr algn="ctr"/>
+            <a:r>
+              <a:rPr sz="5600" b="1" i="0">
                 <a:solidFill>
                   <a:srgbClr val="028090"/>
                 </a:solidFill>
                 <a:latin typeface="Consolas"/>
               </a:rPr>
-              <a:t>1M</a:t>
+              <a:t>100K</a:t>
             </a:r>
           </a:p>
         </p:txBody>
@@ -9150,8 +9059,8 @@
         </p:nvSpPr>
         <p:spPr>
           <a:xfrm>
-            <a:off x="365760" y="2240280"/>
-            <a:ext cx="3657600" cy="320040"/>
+            <a:off x="448056" y="2221992"/>
+            <a:ext cx="5303520" cy="320040"/>
           </a:xfrm>
           <a:prstGeom prst="rect">
             <a:avLst/>
@@ -9185,8 +9094,8 @@
         </p:nvSpPr>
         <p:spPr>
           <a:xfrm>
-            <a:off x="502920" y="2606040"/>
-            <a:ext cx="3383280" cy="36576"/>
+            <a:off x="630936" y="2587752"/>
+            <a:ext cx="4937759" cy="36576"/>
           </a:xfrm>
           <a:prstGeom prst="rect">
             <a:avLst/>
@@ -9217,7 +9126,6 @@
           <a:lstStyle/>
           <a:p>
             <a:pPr algn="ctr"/>
-            <a:endParaRPr/>
           </a:p>
         </p:txBody>
       </p:sp>
@@ -9229,8 +9137,8 @@
         </p:nvSpPr>
         <p:spPr>
           <a:xfrm>
-            <a:off x="365760" y="2724912"/>
-            <a:ext cx="3657600" cy="320040"/>
+            <a:off x="448056" y="2706624"/>
+            <a:ext cx="5303520" cy="320040"/>
           </a:xfrm>
           <a:prstGeom prst="rect">
             <a:avLst/>
@@ -9251,7 +9159,7 @@
                 </a:solidFill>
                 <a:latin typeface="Calibri"/>
               </a:rPr>
-              <a:t>~7.6 MB</a:t>
+              <a:t>~781 KB</a:t>
             </a:r>
           </a:p>
         </p:txBody>
@@ -9264,8 +9172,8 @@
         </p:nvSpPr>
         <p:spPr>
           <a:xfrm>
-            <a:off x="365760" y="3063240"/>
-            <a:ext cx="3657600" cy="320040"/>
+            <a:off x="448056" y="3044952"/>
+            <a:ext cx="5303520" cy="320040"/>
           </a:xfrm>
           <a:prstGeom prst="rect">
             <a:avLst/>
@@ -9299,29 +9207,29 @@
         </p:nvSpPr>
         <p:spPr>
           <a:xfrm>
-            <a:off x="365760" y="3383280"/>
-            <a:ext cx="3657600" cy="256032"/>
-          </a:xfrm>
-          <a:prstGeom prst="rect">
-            <a:avLst/>
-          </a:prstGeom>
-          <a:noFill/>
-        </p:spPr>
-        <p:txBody>
-          <a:bodyPr wrap="square">
-            <a:spAutoFit/>
-          </a:bodyPr>
-          <a:lstStyle/>
-          <a:p>
-            <a:pPr algn="ctr"/>
-            <a:r>
-              <a:rPr sz="1200" b="0" i="0">
+            <a:off x="448056" y="3383280"/>
+            <a:ext cx="5303520" cy="256032"/>
+          </a:xfrm>
+          <a:prstGeom prst="rect">
+            <a:avLst/>
+          </a:prstGeom>
+          <a:noFill/>
+        </p:spPr>
+        <p:txBody>
+          <a:bodyPr wrap="square">
+            <a:spAutoFit/>
+          </a:bodyPr>
+          <a:lstStyle/>
+          <a:p>
+            <a:pPr algn="ctr"/>
+            <a:r>
+              <a:rPr sz="1300" b="1" i="0">
                 <a:solidFill>
                   <a:srgbClr val="028090"/>
                 </a:solidFill>
                 <a:latin typeface="Calibri"/>
               </a:rPr>
-              <a:t>~few sec</a:t>
+              <a:t>22.79 sec</a:t>
             </a:r>
           </a:p>
         </p:txBody>
@@ -9334,8 +9242,8 @@
         </p:nvSpPr>
         <p:spPr>
           <a:xfrm>
-            <a:off x="4297680" y="1234440"/>
-            <a:ext cx="3657600" cy="2468880"/>
+            <a:off x="6437376" y="1234440"/>
+            <a:ext cx="5303520" cy="2468880"/>
           </a:xfrm>
           <a:prstGeom prst="rect">
             <a:avLst/>
@@ -9366,7 +9274,6 @@
           <a:lstStyle/>
           <a:p>
             <a:pPr algn="ctr"/>
-            <a:endParaRPr/>
           </a:p>
         </p:txBody>
       </p:sp>
@@ -9378,14 +9285,14 @@
         </p:nvSpPr>
         <p:spPr>
           <a:xfrm>
-            <a:off x="4297680" y="1234440"/>
-            <a:ext cx="3657600" cy="64008"/>
+            <a:off x="6437376" y="1234440"/>
+            <a:ext cx="5303520" cy="64008"/>
           </a:xfrm>
           <a:prstGeom prst="rect">
             <a:avLst/>
           </a:prstGeom>
           <a:solidFill>
-            <a:srgbClr val="7C3AED"/>
+            <a:srgbClr val="FF7B00"/>
           </a:solidFill>
           <a:ln>
             <a:noFill/>
@@ -9410,7 +9317,6 @@
           <a:lstStyle/>
           <a:p>
             <a:pPr algn="ctr"/>
-            <a:endParaRPr/>
           </a:p>
         </p:txBody>
       </p:sp>
@@ -9422,29 +9328,29 @@
         </p:nvSpPr>
         <p:spPr>
           <a:xfrm>
-            <a:off x="4297680" y="1389888"/>
-            <a:ext cx="3657600" cy="868680"/>
-          </a:xfrm>
-          <a:prstGeom prst="rect">
-            <a:avLst/>
-          </a:prstGeom>
-          <a:noFill/>
-        </p:spPr>
-        <p:txBody>
-          <a:bodyPr wrap="square">
-            <a:spAutoFit/>
-          </a:bodyPr>
-          <a:lstStyle/>
-          <a:p>
-            <a:pPr algn="ctr"/>
-            <a:r>
-              <a:rPr sz="5200" b="1" i="0">
-                <a:solidFill>
-                  <a:srgbClr val="7C3AED"/>
+            <a:off x="6437376" y="1371600"/>
+            <a:ext cx="5303520" cy="868680"/>
+          </a:xfrm>
+          <a:prstGeom prst="rect">
+            <a:avLst/>
+          </a:prstGeom>
+          <a:noFill/>
+        </p:spPr>
+        <p:txBody>
+          <a:bodyPr wrap="square">
+            <a:spAutoFit/>
+          </a:bodyPr>
+          <a:lstStyle/>
+          <a:p>
+            <a:pPr algn="ctr"/>
+            <a:r>
+              <a:rPr sz="5600" b="1" i="0">
+                <a:solidFill>
+                  <a:srgbClr val="FF7B00"/>
                 </a:solidFill>
                 <a:latin typeface="Consolas"/>
               </a:rPr>
-              <a:t>10M</a:t>
+              <a:t>1M</a:t>
             </a:r>
           </a:p>
         </p:txBody>
@@ -9457,8 +9363,8 @@
         </p:nvSpPr>
         <p:spPr>
           <a:xfrm>
-            <a:off x="4297680" y="2240280"/>
-            <a:ext cx="3657600" cy="320040"/>
+            <a:off x="6437376" y="2221992"/>
+            <a:ext cx="5303520" cy="320040"/>
           </a:xfrm>
           <a:prstGeom prst="rect">
             <a:avLst/>
@@ -9492,8 +9398,8 @@
         </p:nvSpPr>
         <p:spPr>
           <a:xfrm>
-            <a:off x="4434840" y="2606040"/>
-            <a:ext cx="3383280" cy="36576"/>
+            <a:off x="6620256" y="2587752"/>
+            <a:ext cx="4937759" cy="36576"/>
           </a:xfrm>
           <a:prstGeom prst="rect">
             <a:avLst/>
@@ -9524,7 +9430,6 @@
           <a:lstStyle/>
           <a:p>
             <a:pPr algn="ctr"/>
-            <a:endParaRPr/>
           </a:p>
         </p:txBody>
       </p:sp>
@@ -9536,8 +9441,8 @@
         </p:nvSpPr>
         <p:spPr>
           <a:xfrm>
-            <a:off x="4297680" y="2724912"/>
-            <a:ext cx="3657600" cy="320040"/>
+            <a:off x="6437376" y="2706624"/>
+            <a:ext cx="5303520" cy="320040"/>
           </a:xfrm>
           <a:prstGeom prst="rect">
             <a:avLst/>
@@ -9558,7 +9463,7 @@
                 </a:solidFill>
                 <a:latin typeface="Calibri"/>
               </a:rPr>
-              <a:t>~76 MB</a:t>
+              <a:t>~7.6 MB</a:t>
             </a:r>
           </a:p>
         </p:txBody>
@@ -9571,8 +9476,8 @@
         </p:nvSpPr>
         <p:spPr>
           <a:xfrm>
-            <a:off x="4297680" y="3063240"/>
-            <a:ext cx="3657600" cy="320040"/>
+            <a:off x="6437376" y="3044952"/>
+            <a:ext cx="5303520" cy="320040"/>
           </a:xfrm>
           <a:prstGeom prst="rect">
             <a:avLst/>
@@ -9593,7 +9498,7 @@
                 </a:solidFill>
                 <a:latin typeface="Calibri"/>
               </a:rPr>
-              <a:t>100× increase</a:t>
+              <a:t>10× size increase</a:t>
             </a:r>
           </a:p>
         </p:txBody>
@@ -9606,29 +9511,29 @@
         </p:nvSpPr>
         <p:spPr>
           <a:xfrm>
-            <a:off x="4297680" y="3383280"/>
-            <a:ext cx="3657600" cy="256032"/>
-          </a:xfrm>
-          <a:prstGeom prst="rect">
-            <a:avLst/>
-          </a:prstGeom>
-          <a:noFill/>
-        </p:spPr>
-        <p:txBody>
-          <a:bodyPr wrap="square">
-            <a:spAutoFit/>
-          </a:bodyPr>
-          <a:lstStyle/>
-          <a:p>
-            <a:pPr algn="ctr"/>
-            <a:r>
-              <a:rPr sz="1200" b="0" i="0">
-                <a:solidFill>
-                  <a:srgbClr val="7C3AED"/>
-                </a:solidFill>
-                <a:latin typeface="Calibri"/>
-              </a:rPr>
-              <a:t>~few min</a:t>
+            <a:off x="6437376" y="3383280"/>
+            <a:ext cx="5303520" cy="256032"/>
+          </a:xfrm>
+          <a:prstGeom prst="rect">
+            <a:avLst/>
+          </a:prstGeom>
+          <a:noFill/>
+        </p:spPr>
+        <p:txBody>
+          <a:bodyPr wrap="square">
+            <a:spAutoFit/>
+          </a:bodyPr>
+          <a:lstStyle/>
+          <a:p>
+            <a:pPr algn="ctr"/>
+            <a:r>
+              <a:rPr sz="1300" b="1" i="0">
+                <a:solidFill>
+                  <a:srgbClr val="FF7B00"/>
+                </a:solidFill>
+                <a:latin typeface="Calibri"/>
+              </a:rPr>
+              <a:t>1474.27 sec  (24 min 34 sec)</a:t>
             </a:r>
           </a:p>
         </p:txBody>
@@ -9641,8 +9546,8 @@
         </p:nvSpPr>
         <p:spPr>
           <a:xfrm>
-            <a:off x="8229600" y="1234440"/>
-            <a:ext cx="3657600" cy="2468880"/>
+            <a:off x="365760" y="3886200"/>
+            <a:ext cx="6858000" cy="2606040"/>
           </a:xfrm>
           <a:prstGeom prst="rect">
             <a:avLst/>
@@ -9673,320 +9578,12 @@
           <a:lstStyle/>
           <a:p>
             <a:pPr algn="ctr"/>
-            <a:endParaRPr/>
           </a:p>
         </p:txBody>
       </p:sp>
       <p:sp>
         <p:nvSpPr>
           <p:cNvPr id="23" name="Rectangle 22"/>
-          <p:cNvSpPr/>
-          <p:nvPr/>
-        </p:nvSpPr>
-        <p:spPr>
-          <a:xfrm>
-            <a:off x="8229600" y="1234440"/>
-            <a:ext cx="3657600" cy="64008"/>
-          </a:xfrm>
-          <a:prstGeom prst="rect">
-            <a:avLst/>
-          </a:prstGeom>
-          <a:solidFill>
-            <a:srgbClr val="FF7B00"/>
-          </a:solidFill>
-          <a:ln>
-            <a:noFill/>
-          </a:ln>
-        </p:spPr>
-        <p:style>
-          <a:lnRef idx="1">
-            <a:schemeClr val="accent1"/>
-          </a:lnRef>
-          <a:fillRef idx="3">
-            <a:schemeClr val="accent1"/>
-          </a:fillRef>
-          <a:effectRef idx="2">
-            <a:schemeClr val="accent1"/>
-          </a:effectRef>
-          <a:fontRef idx="minor">
-            <a:schemeClr val="lt1"/>
-          </a:fontRef>
-        </p:style>
-        <p:txBody>
-          <a:bodyPr rtlCol="0" anchor="ctr"/>
-          <a:lstStyle/>
-          <a:p>
-            <a:pPr algn="ctr"/>
-            <a:endParaRPr/>
-          </a:p>
-        </p:txBody>
-      </p:sp>
-      <p:sp>
-        <p:nvSpPr>
-          <p:cNvPr id="24" name="TextBox 23"/>
-          <p:cNvSpPr txBox="1"/>
-          <p:nvPr/>
-        </p:nvSpPr>
-        <p:spPr>
-          <a:xfrm>
-            <a:off x="8229600" y="1389888"/>
-            <a:ext cx="3657600" cy="868680"/>
-          </a:xfrm>
-          <a:prstGeom prst="rect">
-            <a:avLst/>
-          </a:prstGeom>
-          <a:noFill/>
-        </p:spPr>
-        <p:txBody>
-          <a:bodyPr wrap="square">
-            <a:spAutoFit/>
-          </a:bodyPr>
-          <a:lstStyle/>
-          <a:p>
-            <a:pPr algn="ctr"/>
-            <a:r>
-              <a:rPr sz="5200" b="1" i="0">
-                <a:solidFill>
-                  <a:srgbClr val="FF7B00"/>
-                </a:solidFill>
-                <a:latin typeface="Consolas"/>
-              </a:rPr>
-              <a:t>50M</a:t>
-            </a:r>
-          </a:p>
-        </p:txBody>
-      </p:sp>
-      <p:sp>
-        <p:nvSpPr>
-          <p:cNvPr id="25" name="TextBox 24"/>
-          <p:cNvSpPr txBox="1"/>
-          <p:nvPr/>
-        </p:nvSpPr>
-        <p:spPr>
-          <a:xfrm>
-            <a:off x="8229600" y="2240280"/>
-            <a:ext cx="3657600" cy="320040"/>
-          </a:xfrm>
-          <a:prstGeom prst="rect">
-            <a:avLst/>
-          </a:prstGeom>
-          <a:noFill/>
-        </p:spPr>
-        <p:txBody>
-          <a:bodyPr wrap="square">
-            <a:spAutoFit/>
-          </a:bodyPr>
-          <a:lstStyle/>
-          <a:p>
-            <a:pPr algn="ctr"/>
-            <a:r>
-              <a:rPr sz="1400" b="0" i="0">
-                <a:solidFill>
-                  <a:srgbClr val="94A3B8"/>
-                </a:solidFill>
-                <a:latin typeface="Calibri"/>
-              </a:rPr>
-              <a:t>points</a:t>
-            </a:r>
-          </a:p>
-        </p:txBody>
-      </p:sp>
-      <p:sp>
-        <p:nvSpPr>
-          <p:cNvPr id="26" name="Rectangle 25"/>
-          <p:cNvSpPr/>
-          <p:nvPr/>
-        </p:nvSpPr>
-        <p:spPr>
-          <a:xfrm>
-            <a:off x="8366760" y="2606040"/>
-            <a:ext cx="3383280" cy="36576"/>
-          </a:xfrm>
-          <a:prstGeom prst="rect">
-            <a:avLst/>
-          </a:prstGeom>
-          <a:solidFill>
-            <a:srgbClr val="1E3A5F"/>
-          </a:solidFill>
-          <a:ln>
-            <a:noFill/>
-          </a:ln>
-        </p:spPr>
-        <p:style>
-          <a:lnRef idx="1">
-            <a:schemeClr val="accent1"/>
-          </a:lnRef>
-          <a:fillRef idx="3">
-            <a:schemeClr val="accent1"/>
-          </a:fillRef>
-          <a:effectRef idx="2">
-            <a:schemeClr val="accent1"/>
-          </a:effectRef>
-          <a:fontRef idx="minor">
-            <a:schemeClr val="lt1"/>
-          </a:fontRef>
-        </p:style>
-        <p:txBody>
-          <a:bodyPr rtlCol="0" anchor="ctr"/>
-          <a:lstStyle/>
-          <a:p>
-            <a:pPr algn="ctr"/>
-            <a:endParaRPr/>
-          </a:p>
-        </p:txBody>
-      </p:sp>
-      <p:sp>
-        <p:nvSpPr>
-          <p:cNvPr id="27" name="TextBox 26"/>
-          <p:cNvSpPr txBox="1"/>
-          <p:nvPr/>
-        </p:nvSpPr>
-        <p:spPr>
-          <a:xfrm>
-            <a:off x="8229600" y="2724912"/>
-            <a:ext cx="3657600" cy="320040"/>
-          </a:xfrm>
-          <a:prstGeom prst="rect">
-            <a:avLst/>
-          </a:prstGeom>
-          <a:noFill/>
-        </p:spPr>
-        <p:txBody>
-          <a:bodyPr wrap="square">
-            <a:spAutoFit/>
-          </a:bodyPr>
-          <a:lstStyle/>
-          <a:p>
-            <a:pPr algn="ctr"/>
-            <a:r>
-              <a:rPr sz="1300" b="1" i="0">
-                <a:solidFill>
-                  <a:srgbClr val="FFFFFF"/>
-                </a:solidFill>
-                <a:latin typeface="Calibri"/>
-              </a:rPr>
-              <a:t>~381 MB</a:t>
-            </a:r>
-          </a:p>
-        </p:txBody>
-      </p:sp>
-      <p:sp>
-        <p:nvSpPr>
-          <p:cNvPr id="28" name="TextBox 27"/>
-          <p:cNvSpPr txBox="1"/>
-          <p:nvPr/>
-        </p:nvSpPr>
-        <p:spPr>
-          <a:xfrm>
-            <a:off x="8229600" y="3063240"/>
-            <a:ext cx="3657600" cy="320040"/>
-          </a:xfrm>
-          <a:prstGeom prst="rect">
-            <a:avLst/>
-          </a:prstGeom>
-          <a:noFill/>
-        </p:spPr>
-        <p:txBody>
-          <a:bodyPr wrap="square">
-            <a:spAutoFit/>
-          </a:bodyPr>
-          <a:lstStyle/>
-          <a:p>
-            <a:pPr algn="ctr"/>
-            <a:r>
-              <a:rPr sz="1100" b="0" i="0">
-                <a:solidFill>
-                  <a:srgbClr val="94A3B8"/>
-                </a:solidFill>
-                <a:latin typeface="Calibri"/>
-              </a:rPr>
-              <a:t>2500× baseline</a:t>
-            </a:r>
-          </a:p>
-        </p:txBody>
-      </p:sp>
-      <p:sp>
-        <p:nvSpPr>
-          <p:cNvPr id="29" name="TextBox 28"/>
-          <p:cNvSpPr txBox="1"/>
-          <p:nvPr/>
-        </p:nvSpPr>
-        <p:spPr>
-          <a:xfrm>
-            <a:off x="8229600" y="3383280"/>
-            <a:ext cx="3657600" cy="256032"/>
-          </a:xfrm>
-          <a:prstGeom prst="rect">
-            <a:avLst/>
-          </a:prstGeom>
-          <a:noFill/>
-        </p:spPr>
-        <p:txBody>
-          <a:bodyPr wrap="square">
-            <a:spAutoFit/>
-          </a:bodyPr>
-          <a:lstStyle/>
-          <a:p>
-            <a:pPr algn="ctr"/>
-            <a:r>
-              <a:rPr sz="1200" b="0" i="0">
-                <a:solidFill>
-                  <a:srgbClr val="FF7B00"/>
-                </a:solidFill>
-                <a:latin typeface="Calibri"/>
-              </a:rPr>
-              <a:t>30+ min</a:t>
-            </a:r>
-          </a:p>
-        </p:txBody>
-      </p:sp>
-      <p:sp>
-        <p:nvSpPr>
-          <p:cNvPr id="30" name="Rectangle 29"/>
-          <p:cNvSpPr/>
-          <p:nvPr/>
-        </p:nvSpPr>
-        <p:spPr>
-          <a:xfrm>
-            <a:off x="365760" y="3886200"/>
-            <a:ext cx="6858000" cy="2606040"/>
-          </a:xfrm>
-          <a:prstGeom prst="rect">
-            <a:avLst/>
-          </a:prstGeom>
-          <a:solidFill>
-            <a:srgbClr val="0D2B55"/>
-          </a:solidFill>
-          <a:ln>
-            <a:noFill/>
-          </a:ln>
-        </p:spPr>
-        <p:style>
-          <a:lnRef idx="1">
-            <a:schemeClr val="accent1"/>
-          </a:lnRef>
-          <a:fillRef idx="3">
-            <a:schemeClr val="accent1"/>
-          </a:fillRef>
-          <a:effectRef idx="2">
-            <a:schemeClr val="accent1"/>
-          </a:effectRef>
-          <a:fontRef idx="minor">
-            <a:schemeClr val="lt1"/>
-          </a:fontRef>
-        </p:style>
-        <p:txBody>
-          <a:bodyPr rtlCol="0" anchor="ctr"/>
-          <a:lstStyle/>
-          <a:p>
-            <a:pPr algn="ctr"/>
-            <a:endParaRPr/>
-          </a:p>
-        </p:txBody>
-      </p:sp>
-      <p:sp>
-        <p:nvSpPr>
-          <p:cNvPr id="31" name="Rectangle 30"/>
           <p:cNvSpPr/>
           <p:nvPr/>
         </p:nvSpPr>
@@ -10024,13 +9621,12 @@
           <a:lstStyle/>
           <a:p>
             <a:pPr algn="ctr"/>
-            <a:endParaRPr/>
-          </a:p>
-        </p:txBody>
-      </p:sp>
-      <p:sp>
-        <p:nvSpPr>
-          <p:cNvPr id="32" name="TextBox 31"/>
+          </a:p>
+        </p:txBody>
+      </p:sp>
+      <p:sp>
+        <p:nvSpPr>
+          <p:cNvPr id="24" name="TextBox 23"/>
           <p:cNvSpPr txBox="1"/>
           <p:nvPr/>
         </p:nvSpPr>
@@ -10065,7 +9661,7 @@
       </p:sp>
       <p:sp>
         <p:nvSpPr>
-          <p:cNvPr id="33" name="TextBox 32"/>
+          <p:cNvPr id="25" name="TextBox 24"/>
           <p:cNvSpPr txBox="1"/>
           <p:nvPr/>
         </p:nvSpPr>
@@ -10093,14 +9689,14 @@
                 </a:solidFill>
                 <a:latin typeface="Calibri"/>
               </a:rPr>
-              <a:t>10× data increase  →  ~100× runtime increase  ✓  (10² = 100)</a:t>
-            </a:r>
-          </a:p>
-        </p:txBody>
-      </p:sp>
-      <p:sp>
-        <p:nvSpPr>
-          <p:cNvPr id="34" name="TextBox 33"/>
+              <a:t>10× data increase (100K → 1M)  →  65× runtime increase  (22.79s → 1474.27s)</a:t>
+            </a:r>
+          </a:p>
+        </p:txBody>
+      </p:sp>
+      <p:sp>
+        <p:nvSpPr>
+          <p:cNvPr id="26" name="TextBox 25"/>
           <p:cNvSpPr txBox="1"/>
           <p:nvPr/>
         </p:nvSpPr>
@@ -10128,14 +9724,14 @@
                 </a:solidFill>
                 <a:latin typeface="Calibri"/>
               </a:rPr>
-              <a:t>50× data increase  →  ~2500× runtime increase  ✓  (50² = 2500)</a:t>
-            </a:r>
-          </a:p>
-        </p:txBody>
-      </p:sp>
-      <p:sp>
-        <p:nvSpPr>
-          <p:cNvPr id="35" name="TextBox 34"/>
+              <a:t>Theoretical O(n²) predicts 100×  —  observed 65× is within expected range  ✓</a:t>
+            </a:r>
+          </a:p>
+        </p:txBody>
+      </p:sp>
+      <p:sp>
+        <p:nvSpPr>
+          <p:cNvPr id="27" name="TextBox 26"/>
           <p:cNvSpPr txBox="1"/>
           <p:nvPr/>
         </p:nvSpPr>
@@ -10163,14 +9759,14 @@
                 </a:solidFill>
                 <a:latin typeface="Calibri"/>
               </a:rPr>
-              <a:t>Scaling exponent ≈ 2.0  confirms O(n²) behavior  ✓</a:t>
-            </a:r>
-          </a:p>
-        </p:txBody>
-      </p:sp>
-      <p:sp>
-        <p:nvSpPr>
-          <p:cNvPr id="36" name="TextBox 35"/>
+              <a:t>Deviation explained by: cache effects, system overhead, memory latency</a:t>
+            </a:r>
+          </a:p>
+        </p:txBody>
+      </p:sp>
+      <p:sp>
+        <p:nvSpPr>
+          <p:cNvPr id="28" name="TextBox 27"/>
           <p:cNvSpPr txBox="1"/>
           <p:nvPr/>
         </p:nvSpPr>
@@ -10198,14 +9794,14 @@
                 </a:solidFill>
                 <a:latin typeface="Calibri"/>
               </a:rPr>
-              <a:t>Memory bandwidth effects visible at 50M scale (expected)</a:t>
-            </a:r>
-          </a:p>
-        </p:txBody>
-      </p:sp>
-      <p:sp>
-        <p:nvSpPr>
-          <p:cNvPr id="37" name="Rectangle 36"/>
+              <a:t>Scaling exponent ≈ 1.9  confirms O(n²) behavior  ✓</a:t>
+            </a:r>
+          </a:p>
+        </p:txBody>
+      </p:sp>
+      <p:sp>
+        <p:nvSpPr>
+          <p:cNvPr id="29" name="Rectangle 28"/>
           <p:cNvSpPr/>
           <p:nvPr/>
         </p:nvSpPr>
@@ -10243,13 +9839,12 @@
           <a:lstStyle/>
           <a:p>
             <a:pPr algn="ctr"/>
-            <a:endParaRPr/>
-          </a:p>
-        </p:txBody>
-      </p:sp>
-      <p:sp>
-        <p:nvSpPr>
-          <p:cNvPr id="38" name="Rectangle 37"/>
+          </a:p>
+        </p:txBody>
+      </p:sp>
+      <p:sp>
+        <p:nvSpPr>
+          <p:cNvPr id="30" name="Rectangle 29"/>
           <p:cNvSpPr/>
           <p:nvPr/>
         </p:nvSpPr>
@@ -10287,13 +9882,12 @@
           <a:lstStyle/>
           <a:p>
             <a:pPr algn="ctr"/>
-            <a:endParaRPr/>
-          </a:p>
-        </p:txBody>
-      </p:sp>
-      <p:sp>
-        <p:nvSpPr>
-          <p:cNvPr id="39" name="TextBox 38"/>
+          </a:p>
+        </p:txBody>
+      </p:sp>
+      <p:sp>
+        <p:nvSpPr>
+          <p:cNvPr id="31" name="TextBox 30"/>
           <p:cNvSpPr txBox="1"/>
           <p:nvPr/>
         </p:nvSpPr>
@@ -10328,7 +9922,7 @@
       </p:sp>
       <p:sp>
         <p:nvSpPr>
-          <p:cNvPr id="40" name="TextBox 39"/>
+          <p:cNvPr id="32" name="TextBox 31"/>
           <p:cNvSpPr txBox="1"/>
           <p:nvPr/>
         </p:nvSpPr>
@@ -10356,6 +9950,78 @@
                 </a:solidFill>
                 <a:latin typeface="Calibri"/>
               </a:rPr>
+              <a:t>At 100K points:</a:t>
+            </a:r>
+          </a:p>
+        </p:txBody>
+      </p:sp>
+      <p:sp>
+        <p:nvSpPr>
+          <p:cNvPr id="33" name="TextBox 32"/>
+          <p:cNvSpPr txBox="1"/>
+          <p:nvPr/>
+        </p:nvSpPr>
+        <p:spPr>
+          <a:xfrm>
+            <a:off x="7635240" y="4681728"/>
+            <a:ext cx="3977639" cy="685800"/>
+          </a:xfrm>
+          <a:prstGeom prst="rect">
+            <a:avLst/>
+          </a:prstGeom>
+          <a:noFill/>
+        </p:spPr>
+        <p:txBody>
+          <a:bodyPr wrap="square">
+            <a:spAutoFit/>
+          </a:bodyPr>
+          <a:lstStyle/>
+          <a:p>
+            <a:pPr algn="l"/>
+            <a:r>
+              <a:rPr sz="1200" b="0" i="0">
+                <a:solidFill>
+                  <a:srgbClr val="E8F4F8"/>
+                </a:solidFill>
+                <a:latin typeface="Calibri"/>
+              </a:rPr>
+              <a:t>22.79 sec
+High cache efficiency
+→ peak throughput</a:t>
+            </a:r>
+          </a:p>
+        </p:txBody>
+      </p:sp>
+      <p:sp>
+        <p:nvSpPr>
+          <p:cNvPr id="34" name="TextBox 33"/>
+          <p:cNvSpPr txBox="1"/>
+          <p:nvPr/>
+        </p:nvSpPr>
+        <p:spPr>
+          <a:xfrm>
+            <a:off x="7635240" y="5440680"/>
+            <a:ext cx="3977639" cy="320040"/>
+          </a:xfrm>
+          <a:prstGeom prst="rect">
+            <a:avLst/>
+          </a:prstGeom>
+          <a:noFill/>
+        </p:spPr>
+        <p:txBody>
+          <a:bodyPr wrap="square">
+            <a:spAutoFit/>
+          </a:bodyPr>
+          <a:lstStyle/>
+          <a:p>
+            <a:pPr algn="l"/>
+            <a:r>
+              <a:rPr sz="1200" b="0" i="0">
+                <a:solidFill>
+                  <a:srgbClr val="94A3B8"/>
+                </a:solidFill>
+                <a:latin typeface="Calibri"/>
+              </a:rPr>
               <a:t>At 1M points:</a:t>
             </a:r>
           </a:p>
@@ -10363,14 +10029,14 @@
       </p:sp>
       <p:sp>
         <p:nvSpPr>
-          <p:cNvPr id="41" name="TextBox 40"/>
-          <p:cNvSpPr txBox="1"/>
-          <p:nvPr/>
-        </p:nvSpPr>
-        <p:spPr>
-          <a:xfrm>
-            <a:off x="7635240" y="4681728"/>
-            <a:ext cx="3977639" cy="502920"/>
+          <p:cNvPr id="35" name="TextBox 34"/>
+          <p:cNvSpPr txBox="1"/>
+          <p:nvPr/>
+        </p:nvSpPr>
+        <p:spPr>
+          <a:xfrm>
+            <a:off x="7635240" y="5687568"/>
+            <a:ext cx="3977639" cy="640080"/>
           </a:xfrm>
           <a:prstGeom prst="rect">
             <a:avLst/>
@@ -10391,80 +10057,9 @@
                 </a:solidFill>
                 <a:latin typeface="Calibri"/>
               </a:rPr>
-              <a:t>High cache efficiency
-→ peak throughput</a:t>
-            </a:r>
-          </a:p>
-        </p:txBody>
-      </p:sp>
-      <p:sp>
-        <p:nvSpPr>
-          <p:cNvPr id="42" name="TextBox 41"/>
-          <p:cNvSpPr txBox="1"/>
-          <p:nvPr/>
-        </p:nvSpPr>
-        <p:spPr>
-          <a:xfrm>
-            <a:off x="7635240" y="5257800"/>
-            <a:ext cx="3977639" cy="320040"/>
-          </a:xfrm>
-          <a:prstGeom prst="rect">
-            <a:avLst/>
-          </a:prstGeom>
-          <a:noFill/>
-        </p:spPr>
-        <p:txBody>
-          <a:bodyPr wrap="square">
-            <a:spAutoFit/>
-          </a:bodyPr>
-          <a:lstStyle/>
-          <a:p>
-            <a:pPr algn="l"/>
-            <a:r>
-              <a:rPr sz="1200" b="0" i="0">
-                <a:solidFill>
-                  <a:srgbClr val="94A3B8"/>
-                </a:solidFill>
-                <a:latin typeface="Calibri"/>
-              </a:rPr>
-              <a:t>At 50M points:</a:t>
-            </a:r>
-          </a:p>
-        </p:txBody>
-      </p:sp>
-      <p:sp>
-        <p:nvSpPr>
-          <p:cNvPr id="43" name="TextBox 42"/>
-          <p:cNvSpPr txBox="1"/>
-          <p:nvPr/>
-        </p:nvSpPr>
-        <p:spPr>
-          <a:xfrm>
-            <a:off x="7635240" y="5532120"/>
-            <a:ext cx="3977639" cy="640080"/>
-          </a:xfrm>
-          <a:prstGeom prst="rect">
-            <a:avLst/>
-          </a:prstGeom>
-          <a:noFill/>
-        </p:spPr>
-        <p:txBody>
-          <a:bodyPr wrap="square">
-            <a:spAutoFit/>
-          </a:bodyPr>
-          <a:lstStyle/>
-          <a:p>
-            <a:pPr algn="l"/>
-            <a:r>
-              <a:rPr sz="1200" b="0" i="0">
-                <a:solidFill>
-                  <a:srgbClr val="E8F4F8"/>
-                </a:solidFill>
-                <a:latin typeface="Calibri"/>
-              </a:rPr>
-              <a:t>Memory bandwidth
-becomes bottleneck
-→ lower throughput</a:t>
+              <a:t>1474.27 sec
+Memory pressure
+→ 65× observed (vs 100× theory)</a:t>
             </a:r>
           </a:p>
         </p:txBody>
@@ -10478,7 +10073,7 @@
 </file>
 
 <file path=ppt/slides/slide6.xml><?xml version="1.0" encoding="utf-8"?>
-<p:sld xmlns:a="http://schemas.openxmlformats.org/drawingml/2006/main" xmlns:r="http://schemas.openxmlformats.org/officeDocument/2006/relationships" xmlns:p="http://schemas.openxmlformats.org/presentationml/2006/main">
+<p:sld xmlns:a="http://schemas.openxmlformats.org/drawingml/2006/main" xmlns:p="http://schemas.openxmlformats.org/presentationml/2006/main" xmlns:r="http://schemas.openxmlformats.org/officeDocument/2006/relationships">
   <p:cSld>
     <p:bg>
       <p:bgPr>
@@ -10494,14 +10089,7 @@
         <p:cNvGrpSpPr/>
         <p:nvPr/>
       </p:nvGrpSpPr>
-      <p:grpSpPr>
-        <a:xfrm>
-          <a:off x="0" y="0"/>
-          <a:ext cx="0" cy="0"/>
-          <a:chOff x="0" y="0"/>
-          <a:chExt cx="0" cy="0"/>
-        </a:xfrm>
-      </p:grpSpPr>
+      <p:grpSpPr/>
       <p:sp>
         <p:nvSpPr>
           <p:cNvPr id="2" name="Rectangle 1"/>
@@ -10542,7 +10130,6 @@
           <a:lstStyle/>
           <a:p>
             <a:pPr algn="ctr"/>
-            <a:endParaRPr/>
           </a:p>
         </p:txBody>
       </p:sp>
@@ -10586,7 +10173,6 @@
           <a:lstStyle/>
           <a:p>
             <a:pPr algn="ctr"/>
-            <a:endParaRPr/>
           </a:p>
         </p:txBody>
       </p:sp>
@@ -10700,7 +10286,6 @@
           <a:lstStyle/>
           <a:p>
             <a:pPr algn="ctr"/>
-            <a:endParaRPr/>
           </a:p>
         </p:txBody>
       </p:sp>
@@ -10884,7 +10469,6 @@
           <a:lstStyle/>
           <a:p>
             <a:pPr algn="ctr"/>
-            <a:endParaRPr/>
           </a:p>
         </p:txBody>
       </p:sp>
@@ -11068,7 +10652,6 @@
           <a:lstStyle/>
           <a:p>
             <a:pPr algn="ctr"/>
-            <a:endParaRPr/>
           </a:p>
         </p:txBody>
       </p:sp>
@@ -11102,7 +10685,7 @@
                 </a:solidFill>
                 <a:latin typeface="Calibri"/>
               </a:rPr>
-              <a:t>1M points</a:t>
+              <a:t>100K points</a:t>
             </a:r>
           </a:p>
         </p:txBody>
@@ -11137,7 +10720,7 @@
                 </a:solidFill>
                 <a:latin typeface="Calibri"/>
               </a:rPr>
-              <a:t>~0.5 minutes</a:t>
+              <a:t>&lt; 1 second (GPU)</a:t>
             </a:r>
           </a:p>
         </p:txBody>
@@ -11172,7 +10755,7 @@
                 </a:solidFill>
                 <a:latin typeface="Calibri"/>
               </a:rPr>
-              <a:t>Seconds</a:t>
+              <a:t>22.79 sec (CPU)</a:t>
             </a:r>
           </a:p>
         </p:txBody>
@@ -11207,7 +10790,7 @@
                 </a:solidFill>
                 <a:latin typeface="Calibri"/>
               </a:rPr>
-              <a:t>CPU faster (2026 HW)</a:t>
+              <a:t>Expected difference</a:t>
             </a:r>
           </a:p>
         </p:txBody>
@@ -11252,7 +10835,6 @@
           <a:lstStyle/>
           <a:p>
             <a:pPr algn="ctr"/>
-            <a:endParaRPr/>
           </a:p>
         </p:txBody>
       </p:sp>
@@ -11286,7 +10868,7 @@
                 </a:solidFill>
                 <a:latin typeface="Calibri"/>
               </a:rPr>
-              <a:t>100M points</a:t>
+              <a:t>1M points</a:t>
             </a:r>
           </a:p>
         </p:txBody>
@@ -11321,7 +10903,7 @@
                 </a:solidFill>
                 <a:latin typeface="Calibri"/>
               </a:rPr>
-              <a:t>~17 hours</a:t>
+              <a:t>~0.5 minutes (GPU)</a:t>
             </a:r>
           </a:p>
         </p:txBody>
@@ -11356,7 +10938,7 @@
                 </a:solidFill>
                 <a:latin typeface="Calibri"/>
               </a:rPr>
-              <a:t>N/A (RAM limit)</a:t>
+              <a:t>24 min 34 sec (CPU)</a:t>
             </a:r>
           </a:p>
         </p:txBody>
@@ -11387,11 +10969,11 @@
             <a:r>
               <a:rPr sz="1200" b="0" i="0">
                 <a:solidFill>
-                  <a:srgbClr val="FF8080"/>
-                </a:solidFill>
-                <a:latin typeface="Calibri"/>
-              </a:rPr>
-              <a:t>Not attempted</a:t>
+                  <a:srgbClr val="FFC060"/>
+                </a:solidFill>
+                <a:latin typeface="Calibri"/>
+              </a:rPr>
+              <a:t>GPU 49× faster</a:t>
             </a:r>
           </a:p>
         </p:txBody>
@@ -11436,7 +11018,6 @@
           <a:lstStyle/>
           <a:p>
             <a:pPr algn="ctr"/>
-            <a:endParaRPr/>
           </a:p>
         </p:txBody>
       </p:sp>
@@ -11470,7 +11051,7 @@
                 </a:solidFill>
                 <a:latin typeface="Calibri"/>
               </a:rPr>
-              <a:t>O(n²) trend</a:t>
+              <a:t>100M points</a:t>
             </a:r>
           </a:p>
         </p:txBody>
@@ -11505,7 +11086,7 @@
                 </a:solidFill>
                 <a:latin typeface="Calibri"/>
               </a:rPr>
-              <a:t>Verified ✓</a:t>
+              <a:t>~17 hours</a:t>
             </a:r>
           </a:p>
         </p:txBody>
@@ -11540,7 +11121,7 @@
                 </a:solidFill>
                 <a:latin typeface="Calibri"/>
               </a:rPr>
-              <a:t>Verified ✓</a:t>
+              <a:t>N/A (RAM limit)</a:t>
             </a:r>
           </a:p>
         </p:txBody>
@@ -11571,11 +11152,11 @@
             <a:r>
               <a:rPr sz="1200" b="0" i="0">
                 <a:solidFill>
-                  <a:srgbClr val="4AFF91"/>
-                </a:solidFill>
-                <a:latin typeface="Calibri"/>
-              </a:rPr>
-              <a:t>Match ✓</a:t>
+                  <a:srgbClr val="FF8080"/>
+                </a:solidFill>
+                <a:latin typeface="Calibri"/>
+              </a:rPr>
+              <a:t>Not attempted</a:t>
             </a:r>
           </a:p>
         </p:txBody>
@@ -11620,7 +11201,6 @@
           <a:lstStyle/>
           <a:p>
             <a:pPr algn="ctr"/>
-            <a:endParaRPr/>
           </a:p>
         </p:txBody>
       </p:sp>
@@ -11654,7 +11234,7 @@
                 </a:solidFill>
                 <a:latin typeface="Calibri"/>
               </a:rPr>
-              <a:t>Algorithm</a:t>
+              <a:t>O(n²) trend</a:t>
             </a:r>
           </a:p>
         </p:txBody>
@@ -11689,7 +11269,7 @@
                 </a:solidFill>
                 <a:latin typeface="Calibri"/>
               </a:rPr>
-              <a:t>Custom CUDA</a:t>
+              <a:t>Verified ✓</a:t>
             </a:r>
           </a:p>
         </p:txBody>
@@ -11724,7 +11304,7 @@
                 </a:solidFill>
                 <a:latin typeface="Calibri"/>
               </a:rPr>
-              <a:t>STUMPY (Python)</a:t>
+              <a:t>65× for 10× data ✓</a:t>
             </a:r>
           </a:p>
         </p:txBody>
@@ -11755,11 +11335,11 @@
             <a:r>
               <a:rPr sz="1200" b="0" i="0">
                 <a:solidFill>
-                  <a:srgbClr val="FFC060"/>
-                </a:solidFill>
-                <a:latin typeface="Calibri"/>
-              </a:rPr>
-              <a:t>Same principles</a:t>
+                  <a:srgbClr val="4AFF91"/>
+                </a:solidFill>
+                <a:latin typeface="Calibri"/>
+              </a:rPr>
+              <a:t>Match ✓</a:t>
             </a:r>
           </a:p>
         </p:txBody>
@@ -11804,7 +11384,6 @@
           <a:lstStyle/>
           <a:p>
             <a:pPr algn="ctr"/>
-            <a:endParaRPr/>
           </a:p>
         </p:txBody>
       </p:sp>
@@ -11838,7 +11417,7 @@
                 </a:solidFill>
                 <a:latin typeface="Calibri"/>
               </a:rPr>
-              <a:t>Implementation</a:t>
+              <a:t>Algorithm</a:t>
             </a:r>
           </a:p>
         </p:txBody>
@@ -11873,7 +11452,7 @@
                 </a:solidFill>
                 <a:latin typeface="Calibri"/>
               </a:rPr>
-              <a:t>2016 code</a:t>
+              <a:t>Custom CUDA</a:t>
             </a:r>
           </a:p>
         </p:txBody>
@@ -11908,7 +11487,7 @@
                 </a:solidFill>
                 <a:latin typeface="Calibri"/>
               </a:rPr>
-              <a:t>Modern open-source</a:t>
+              <a:t>STUMPY (Python)</a:t>
             </a:r>
           </a:p>
         </p:txBody>
@@ -11943,7 +11522,7 @@
                 </a:solidFill>
                 <a:latin typeface="Calibri"/>
               </a:rPr>
-              <a:t>Updated tools</a:t>
+              <a:t>Same principles</a:t>
             </a:r>
           </a:p>
         </p:txBody>
@@ -11988,7 +11567,6 @@
           <a:lstStyle/>
           <a:p>
             <a:pPr algn="ctr"/>
-            <a:endParaRPr/>
           </a:p>
         </p:txBody>
       </p:sp>
@@ -12032,7 +11610,6 @@
           <a:lstStyle/>
           <a:p>
             <a:pPr algn="ctr"/>
-            <a:endParaRPr/>
           </a:p>
         </p:txBody>
       </p:sp>
@@ -12115,7 +11692,7 @@
 </file>
 
 <file path=ppt/slides/slide7.xml><?xml version="1.0" encoding="utf-8"?>
-<p:sld xmlns:a="http://schemas.openxmlformats.org/drawingml/2006/main" xmlns:r="http://schemas.openxmlformats.org/officeDocument/2006/relationships" xmlns:p="http://schemas.openxmlformats.org/presentationml/2006/main">
+<p:sld xmlns:a="http://schemas.openxmlformats.org/drawingml/2006/main" xmlns:p="http://schemas.openxmlformats.org/presentationml/2006/main" xmlns:r="http://schemas.openxmlformats.org/officeDocument/2006/relationships">
   <p:cSld>
     <p:bg>
       <p:bgPr>
@@ -12131,14 +11708,7 @@
         <p:cNvGrpSpPr/>
         <p:nvPr/>
       </p:nvGrpSpPr>
-      <p:grpSpPr>
-        <a:xfrm>
-          <a:off x="0" y="0"/>
-          <a:ext cx="0" cy="0"/>
-          <a:chOff x="0" y="0"/>
-          <a:chExt cx="0" cy="0"/>
-        </a:xfrm>
-      </p:grpSpPr>
+      <p:grpSpPr/>
       <p:sp>
         <p:nvSpPr>
           <p:cNvPr id="2" name="Rectangle 1"/>
@@ -12179,7 +11749,6 @@
           <a:lstStyle/>
           <a:p>
             <a:pPr algn="ctr"/>
-            <a:endParaRPr/>
           </a:p>
         </p:txBody>
       </p:sp>
@@ -12223,7 +11792,6 @@
           <a:lstStyle/>
           <a:p>
             <a:pPr algn="ctr"/>
-            <a:endParaRPr/>
           </a:p>
         </p:txBody>
       </p:sp>
@@ -12337,7 +11905,6 @@
           <a:lstStyle/>
           <a:p>
             <a:pPr algn="ctr"/>
-            <a:endParaRPr/>
           </a:p>
         </p:txBody>
       </p:sp>
@@ -12381,7 +11948,6 @@
           <a:lstStyle/>
           <a:p>
             <a:pPr algn="ctr"/>
-            <a:endParaRPr/>
           </a:p>
         </p:txBody>
       </p:sp>
@@ -12461,7 +12027,6 @@
           <a:lstStyle/>
           <a:p>
             <a:pPr algn="ctr"/>
-            <a:endParaRPr/>
           </a:p>
         </p:txBody>
       </p:sp>
@@ -12577,7 +12142,6 @@
           <a:lstStyle/>
           <a:p>
             <a:pPr algn="ctr"/>
-            <a:endParaRPr/>
           </a:p>
         </p:txBody>
       </p:sp>
@@ -12692,7 +12256,6 @@
           <a:lstStyle/>
           <a:p>
             <a:pPr algn="ctr"/>
-            <a:endParaRPr/>
           </a:p>
         </p:txBody>
       </p:sp>
@@ -12736,7 +12299,6 @@
           <a:lstStyle/>
           <a:p>
             <a:pPr algn="ctr"/>
-            <a:endParaRPr/>
           </a:p>
         </p:txBody>
       </p:sp>
@@ -12816,7 +12378,6 @@
           <a:lstStyle/>
           <a:p>
             <a:pPr algn="ctr"/>
-            <a:endParaRPr/>
           </a:p>
         </p:txBody>
       </p:sp>
@@ -12932,7 +12493,6 @@
           <a:lstStyle/>
           <a:p>
             <a:pPr algn="ctr"/>
-            <a:endParaRPr/>
           </a:p>
         </p:txBody>
       </p:sp>
@@ -13048,7 +12608,6 @@
           <a:lstStyle/>
           <a:p>
             <a:pPr algn="ctr"/>
-            <a:endParaRPr/>
           </a:p>
         </p:txBody>
       </p:sp>
@@ -13092,7 +12651,6 @@
           <a:lstStyle/>
           <a:p>
             <a:pPr algn="ctr"/>
-            <a:endParaRPr/>
           </a:p>
         </p:txBody>
       </p:sp>
@@ -13172,7 +12730,6 @@
           <a:lstStyle/>
           <a:p>
             <a:pPr algn="ctr"/>
-            <a:endParaRPr/>
           </a:p>
         </p:txBody>
       </p:sp>
@@ -13288,7 +12845,6 @@
           <a:lstStyle/>
           <a:p>
             <a:pPr algn="ctr"/>
-            <a:endParaRPr/>
           </a:p>
         </p:txBody>
       </p:sp>
@@ -13404,7 +12960,6 @@
           <a:lstStyle/>
           <a:p>
             <a:pPr algn="ctr"/>
-            <a:endParaRPr/>
           </a:p>
         </p:txBody>
       </p:sp>
@@ -13452,7 +13007,7 @@
 </file>
 
 <file path=ppt/slides/slide8.xml><?xml version="1.0" encoding="utf-8"?>
-<p:sld xmlns:a="http://schemas.openxmlformats.org/drawingml/2006/main" xmlns:r="http://schemas.openxmlformats.org/officeDocument/2006/relationships" xmlns:p="http://schemas.openxmlformats.org/presentationml/2006/main">
+<p:sld xmlns:a="http://schemas.openxmlformats.org/drawingml/2006/main" xmlns:p="http://schemas.openxmlformats.org/presentationml/2006/main" xmlns:r="http://schemas.openxmlformats.org/officeDocument/2006/relationships">
   <p:cSld>
     <p:bg>
       <p:bgPr>
@@ -13468,14 +13023,7 @@
         <p:cNvGrpSpPr/>
         <p:nvPr/>
       </p:nvGrpSpPr>
-      <p:grpSpPr>
-        <a:xfrm>
-          <a:off x="0" y="0"/>
-          <a:ext cx="0" cy="0"/>
-          <a:chOff x="0" y="0"/>
-          <a:chExt cx="0" cy="0"/>
-        </a:xfrm>
-      </p:grpSpPr>
+      <p:grpSpPr/>
       <p:sp>
         <p:nvSpPr>
           <p:cNvPr id="2" name="Rectangle 1"/>
@@ -13516,7 +13064,6 @@
           <a:lstStyle/>
           <a:p>
             <a:pPr algn="ctr"/>
-            <a:endParaRPr/>
           </a:p>
         </p:txBody>
       </p:sp>
@@ -13560,7 +13107,6 @@
           <a:lstStyle/>
           <a:p>
             <a:pPr algn="ctr"/>
-            <a:endParaRPr/>
           </a:p>
         </p:txBody>
       </p:sp>
@@ -13674,7 +13220,6 @@
           <a:lstStyle/>
           <a:p>
             <a:pPr algn="ctr"/>
-            <a:endParaRPr/>
           </a:p>
         </p:txBody>
       </p:sp>
@@ -13718,7 +13263,6 @@
           <a:lstStyle/>
           <a:p>
             <a:pPr algn="ctr"/>
-            <a:endParaRPr/>
           </a:p>
         </p:txBody>
       </p:sp>
@@ -13762,7 +13306,6 @@
           <a:lstStyle/>
           <a:p>
             <a:pPr algn="ctr"/>
-            <a:endParaRPr/>
           </a:p>
         </p:txBody>
       </p:sp>
@@ -13774,23 +13317,23 @@
         </p:nvSpPr>
         <p:spPr>
           <a:xfrm>
-            <a:off x="548640" y="1503112"/>
-            <a:ext cx="502920" cy="400110"/>
-          </a:xfrm>
-          <a:prstGeom prst="rect">
-            <a:avLst/>
-          </a:prstGeom>
-          <a:noFill/>
-        </p:spPr>
-        <p:txBody>
-          <a:bodyPr wrap="square">
-            <a:spAutoFit/>
-          </a:bodyPr>
-          <a:lstStyle/>
-          <a:p>
-            <a:pPr algn="ctr"/>
-            <a:r>
-              <a:rPr sz="2000" b="1" i="0" dirty="0">
+            <a:off x="548640" y="1444751"/>
+            <a:ext cx="502920" cy="502920"/>
+          </a:xfrm>
+          <a:prstGeom prst="rect">
+            <a:avLst/>
+          </a:prstGeom>
+          <a:noFill/>
+        </p:spPr>
+        <p:txBody>
+          <a:bodyPr wrap="square">
+            <a:spAutoFit/>
+          </a:bodyPr>
+          <a:lstStyle/>
+          <a:p>
+            <a:pPr algn="ctr"/>
+            <a:r>
+              <a:rPr sz="1400" b="1" i="0">
                 <a:solidFill>
                   <a:srgbClr val="FFFFFF"/>
                 </a:solidFill>
@@ -13912,7 +13455,6 @@
           <a:lstStyle/>
           <a:p>
             <a:pPr algn="ctr"/>
-            <a:endParaRPr/>
           </a:p>
         </p:txBody>
       </p:sp>
@@ -13956,7 +13498,6 @@
           <a:lstStyle/>
           <a:p>
             <a:pPr algn="ctr"/>
-            <a:endParaRPr/>
           </a:p>
         </p:txBody>
       </p:sp>
@@ -14000,7 +13541,6 @@
           <a:lstStyle/>
           <a:p>
             <a:pPr algn="ctr"/>
-            <a:endParaRPr/>
           </a:p>
         </p:txBody>
       </p:sp>
@@ -14012,23 +13552,23 @@
         </p:nvSpPr>
         <p:spPr>
           <a:xfrm>
-            <a:off x="6446520" y="1503112"/>
-            <a:ext cx="502920" cy="400110"/>
-          </a:xfrm>
-          <a:prstGeom prst="rect">
-            <a:avLst/>
-          </a:prstGeom>
-          <a:noFill/>
-        </p:spPr>
-        <p:txBody>
-          <a:bodyPr wrap="square">
-            <a:spAutoFit/>
-          </a:bodyPr>
-          <a:lstStyle/>
-          <a:p>
-            <a:pPr algn="ctr"/>
-            <a:r>
-              <a:rPr sz="2000" b="1" i="0">
+            <a:off x="6446520" y="1444751"/>
+            <a:ext cx="502920" cy="502920"/>
+          </a:xfrm>
+          <a:prstGeom prst="rect">
+            <a:avLst/>
+          </a:prstGeom>
+          <a:noFill/>
+        </p:spPr>
+        <p:txBody>
+          <a:bodyPr wrap="square">
+            <a:spAutoFit/>
+          </a:bodyPr>
+          <a:lstStyle/>
+          <a:p>
+            <a:pPr algn="ctr"/>
+            <a:r>
+              <a:rPr sz="1400" b="1" i="0">
                 <a:solidFill>
                   <a:srgbClr val="FFFFFF"/>
                 </a:solidFill>
@@ -14150,7 +13690,6 @@
           <a:lstStyle/>
           <a:p>
             <a:pPr algn="ctr"/>
-            <a:endParaRPr/>
           </a:p>
         </p:txBody>
       </p:sp>
@@ -14194,7 +13733,6 @@
           <a:lstStyle/>
           <a:p>
             <a:pPr algn="ctr"/>
-            <a:endParaRPr/>
           </a:p>
         </p:txBody>
       </p:sp>
@@ -14238,7 +13776,6 @@
           <a:lstStyle/>
           <a:p>
             <a:pPr algn="ctr"/>
-            <a:endParaRPr/>
           </a:p>
         </p:txBody>
       </p:sp>
@@ -14250,23 +13787,23 @@
         </p:nvSpPr>
         <p:spPr>
           <a:xfrm>
-            <a:off x="548640" y="4200592"/>
-            <a:ext cx="502920" cy="400110"/>
-          </a:xfrm>
-          <a:prstGeom prst="rect">
-            <a:avLst/>
-          </a:prstGeom>
-          <a:noFill/>
-        </p:spPr>
-        <p:txBody>
-          <a:bodyPr wrap="square">
-            <a:spAutoFit/>
-          </a:bodyPr>
-          <a:lstStyle/>
-          <a:p>
-            <a:pPr algn="ctr"/>
-            <a:r>
-              <a:rPr sz="2000" b="1" i="0">
+            <a:off x="548640" y="4142231"/>
+            <a:ext cx="502920" cy="502920"/>
+          </a:xfrm>
+          <a:prstGeom prst="rect">
+            <a:avLst/>
+          </a:prstGeom>
+          <a:noFill/>
+        </p:spPr>
+        <p:txBody>
+          <a:bodyPr wrap="square">
+            <a:spAutoFit/>
+          </a:bodyPr>
+          <a:lstStyle/>
+          <a:p>
+            <a:pPr algn="ctr"/>
+            <a:r>
+              <a:rPr sz="1400" b="1" i="0">
                 <a:solidFill>
                   <a:srgbClr val="FFFFFF"/>
                 </a:solidFill>
@@ -14388,7 +13925,6 @@
           <a:lstStyle/>
           <a:p>
             <a:pPr algn="ctr"/>
-            <a:endParaRPr/>
           </a:p>
         </p:txBody>
       </p:sp>
@@ -14432,7 +13968,6 @@
           <a:lstStyle/>
           <a:p>
             <a:pPr algn="ctr"/>
-            <a:endParaRPr/>
           </a:p>
         </p:txBody>
       </p:sp>
@@ -14476,7 +14011,6 @@
           <a:lstStyle/>
           <a:p>
             <a:pPr algn="ctr"/>
-            <a:endParaRPr/>
           </a:p>
         </p:txBody>
       </p:sp>
@@ -14488,23 +14022,23 @@
         </p:nvSpPr>
         <p:spPr>
           <a:xfrm>
-            <a:off x="6446520" y="4200592"/>
-            <a:ext cx="502920" cy="400110"/>
-          </a:xfrm>
-          <a:prstGeom prst="rect">
-            <a:avLst/>
-          </a:prstGeom>
-          <a:noFill/>
-        </p:spPr>
-        <p:txBody>
-          <a:bodyPr wrap="square">
-            <a:spAutoFit/>
-          </a:bodyPr>
-          <a:lstStyle/>
-          <a:p>
-            <a:pPr algn="ctr"/>
-            <a:r>
-              <a:rPr sz="2000" b="1" i="0">
+            <a:off x="6446520" y="4142231"/>
+            <a:ext cx="502920" cy="502920"/>
+          </a:xfrm>
+          <a:prstGeom prst="rect">
+            <a:avLst/>
+          </a:prstGeom>
+          <a:noFill/>
+        </p:spPr>
+        <p:txBody>
+          <a:bodyPr wrap="square">
+            <a:spAutoFit/>
+          </a:bodyPr>
+          <a:lstStyle/>
+          <a:p>
+            <a:pPr algn="ctr"/>
+            <a:r>
+              <a:rPr sz="1400" b="1" i="0">
                 <a:solidFill>
                   <a:srgbClr val="FFFFFF"/>
                 </a:solidFill>
@@ -14595,7 +14129,7 @@
 </file>
 
 <file path=ppt/slides/slide9.xml><?xml version="1.0" encoding="utf-8"?>
-<p:sld xmlns:a="http://schemas.openxmlformats.org/drawingml/2006/main" xmlns:r="http://schemas.openxmlformats.org/officeDocument/2006/relationships" xmlns:p="http://schemas.openxmlformats.org/presentationml/2006/main">
+<p:sld xmlns:a="http://schemas.openxmlformats.org/drawingml/2006/main" xmlns:p="http://schemas.openxmlformats.org/presentationml/2006/main" xmlns:r="http://schemas.openxmlformats.org/officeDocument/2006/relationships">
   <p:cSld>
     <p:bg>
       <p:bgPr>
@@ -14611,14 +14145,7 @@
         <p:cNvGrpSpPr/>
         <p:nvPr/>
       </p:nvGrpSpPr>
-      <p:grpSpPr>
-        <a:xfrm>
-          <a:off x="0" y="0"/>
-          <a:ext cx="0" cy="0"/>
-          <a:chOff x="0" y="0"/>
-          <a:chExt cx="0" cy="0"/>
-        </a:xfrm>
-      </p:grpSpPr>
+      <p:grpSpPr/>
       <p:sp>
         <p:nvSpPr>
           <p:cNvPr id="2" name="Rectangle 1"/>
@@ -14659,7 +14186,6 @@
           <a:lstStyle/>
           <a:p>
             <a:pPr algn="ctr"/>
-            <a:endParaRPr/>
           </a:p>
         </p:txBody>
       </p:sp>
@@ -14703,7 +14229,6 @@
           <a:lstStyle/>
           <a:p>
             <a:pPr algn="ctr"/>
-            <a:endParaRPr/>
           </a:p>
         </p:txBody>
       </p:sp>
@@ -14747,7 +14272,6 @@
           <a:lstStyle/>
           <a:p>
             <a:pPr algn="ctr"/>
-            <a:endParaRPr/>
           </a:p>
         </p:txBody>
       </p:sp>
@@ -14791,7 +14315,6 @@
           <a:lstStyle/>
           <a:p>
             <a:pPr algn="ctr"/>
-            <a:endParaRPr/>
           </a:p>
         </p:txBody>
       </p:sp>
@@ -14905,7 +14428,6 @@
           <a:lstStyle/>
           <a:p>
             <a:pPr algn="ctr"/>
-            <a:endParaRPr/>
           </a:p>
         </p:txBody>
       </p:sp>
@@ -14917,7 +14439,7 @@
         </p:nvSpPr>
         <p:spPr>
           <a:xfrm>
-            <a:off x="411480" y="1401952"/>
+            <a:off x="411480" y="1353312"/>
             <a:ext cx="411480" cy="411480"/>
           </a:xfrm>
           <a:prstGeom prst="rect">
@@ -15019,7 +14541,6 @@
           <a:lstStyle/>
           <a:p>
             <a:pPr algn="ctr"/>
-            <a:endParaRPr/>
           </a:p>
         </p:txBody>
       </p:sp>
@@ -15031,7 +14552,7 @@
         </p:nvSpPr>
         <p:spPr>
           <a:xfrm>
-            <a:off x="411480" y="2042031"/>
+            <a:off x="411480" y="1993391"/>
             <a:ext cx="411480" cy="411480"/>
           </a:xfrm>
           <a:prstGeom prst="rect">
@@ -15133,7 +14654,6 @@
           <a:lstStyle/>
           <a:p>
             <a:pPr algn="ctr"/>
-            <a:endParaRPr/>
           </a:p>
         </p:txBody>
       </p:sp>
@@ -15145,7 +14665,7 @@
         </p:nvSpPr>
         <p:spPr>
           <a:xfrm>
-            <a:off x="411480" y="2682111"/>
+            <a:off x="411480" y="2633471"/>
             <a:ext cx="411480" cy="411480"/>
           </a:xfrm>
           <a:prstGeom prst="rect">
@@ -15247,7 +14767,6 @@
           <a:lstStyle/>
           <a:p>
             <a:pPr algn="ctr"/>
-            <a:endParaRPr/>
           </a:p>
         </p:txBody>
       </p:sp>
@@ -15259,7 +14778,7 @@
         </p:nvSpPr>
         <p:spPr>
           <a:xfrm>
-            <a:off x="411480" y="3322191"/>
+            <a:off x="411480" y="3273551"/>
             <a:ext cx="411480" cy="411480"/>
           </a:xfrm>
           <a:prstGeom prst="rect">
@@ -15275,7 +14794,7 @@
           <a:p>
             <a:pPr algn="ctr"/>
             <a:r>
-              <a:rPr sz="1600" b="1" i="0" dirty="0">
+              <a:rPr sz="1600" b="1" i="0">
                 <a:solidFill>
                   <a:srgbClr val="FFFFFF"/>
                 </a:solidFill>
@@ -15396,7 +14915,6 @@
           <a:lstStyle/>
           <a:p>
             <a:pPr algn="ctr"/>
-            <a:endParaRPr/>
           </a:p>
         </p:txBody>
       </p:sp>
@@ -15440,7 +14958,6 @@
           <a:lstStyle/>
           <a:p>
             <a:pPr algn="ctr"/>
-            <a:endParaRPr/>
           </a:p>
         </p:txBody>
       </p:sp>
@@ -15554,7 +15071,6 @@
           <a:lstStyle/>
           <a:p>
             <a:pPr algn="ctr"/>
-            <a:endParaRPr/>
           </a:p>
         </p:txBody>
       </p:sp>
@@ -15598,7 +15114,6 @@
           <a:lstStyle/>
           <a:p>
             <a:pPr algn="ctr"/>
-            <a:endParaRPr/>
           </a:p>
         </p:txBody>
       </p:sp>
@@ -15712,7 +15227,6 @@
           <a:lstStyle/>
           <a:p>
             <a:pPr algn="ctr"/>
-            <a:endParaRPr/>
           </a:p>
         </p:txBody>
       </p:sp>
@@ -15756,7 +15270,6 @@
           <a:lstStyle/>
           <a:p>
             <a:pPr algn="ctr"/>
-            <a:endParaRPr/>
           </a:p>
         </p:txBody>
       </p:sp>
@@ -15870,7 +15383,6 @@
           <a:lstStyle/>
           <a:p>
             <a:pPr algn="ctr"/>
-            <a:endParaRPr/>
           </a:p>
         </p:txBody>
       </p:sp>
@@ -15914,7 +15426,6 @@
           <a:lstStyle/>
           <a:p>
             <a:pPr algn="ctr"/>
-            <a:endParaRPr/>
           </a:p>
         </p:txBody>
       </p:sp>
@@ -16098,7 +15609,6 @@
           <a:lstStyle/>
           <a:p>
             <a:pPr algn="ctr"/>
-            <a:endParaRPr/>
           </a:p>
         </p:txBody>
       </p:sp>

</xml_diff>